<commit_message>
Atualizar os 3 modelos com os arquivos oficiais mais recentes do time
O time mandou 3 arquivos novos de referencia (Aula 01 - Windows 10, PETROBRAS
MQ Bloco 3, Atualidades Maio 2026). Mudancas de estrutura:

- Apresentacao padrao: o exemplo antigo (PETR Gestao de Riscos) era simples
  demais (so texto+imagem). O real tem 22 variacoes visuais (tabelas,
  galerias, grupos) -- decidido manter escopo simples por agora: clona o
  padrao mais comum (titulo curto + definicao), sem tentar replicar
  tabelas/galerias. Por isso o schema do petr ganhou o campo 'titulo'.
- Mestre em Questoes: estrutura idêntica, só o nome do shape mudou (sem
  acento: "Retangulo 1").
- Atualidades: agora toda noticia tem categoria (antes era so 5 de 40) e 1
  imagem por noticia em vez de 2 -- schema ganhou o campo 'categoria'.

Templates podados como antes (so capa+abertura+slide-fonte), Atualidades
caiu de 72.5MB pra 0.3MB.
</commit_message>
<xml_diff>
--- a/pptx_templates/Atualidades_modelo.pptx
+++ b/pptx_templates/Atualidades_modelo.pptx
@@ -2,20 +2,20 @@
 <file path=ppt/presentation.xml><?xml version="1.0" encoding="utf-8"?>
 <p:presentation xmlns:a="http://schemas.openxmlformats.org/drawingml/2006/main" xmlns:r="http://schemas.openxmlformats.org/officeDocument/2006/relationships" xmlns:p="http://schemas.openxmlformats.org/presentationml/2006/main" saveSubsetFonts="1">
   <p:sldMasterIdLst>
-    <p:sldMasterId id="2147483696" r:id="rId1"/>
+    <p:sldMasterId id="2147483720" r:id="rId1"/>
   </p:sldMasterIdLst>
   <p:notesMasterIdLst>
-    <p:notesMasterId r:id="rId42"/>
+    <p:notesMasterId r:id="rId40"/>
   </p:notesMasterIdLst>
   <p:sldIdLst>
     <p:sldId id="268" r:id="rId2"/>
     <p:sldId id="317" r:id="rId3"/>
-    <p:sldId id="599" r:id="rId5"/>
+    <p:sldId id="728" r:id="rId4"/>
   </p:sldIdLst>
   <p:sldSz cx="12192000" cy="6858000"/>
   <p:notesSz cx="6858000" cy="9144000"/>
   <p:custDataLst>
-    <p:tags r:id="rId43"/>
+    <p:tags r:id="rId41"/>
   </p:custDataLst>
   <p:defaultTextStyle>
     <a:defPPr>
@@ -114,7 +114,53 @@
   </p:defaultTextStyle>
   <p:extLst>
     <p:ext uri="{EFAFB233-063F-42B5-8137-9DF3F51BA10A}">
-      <p15:sldGuideLst xmlns:p15="http://schemas.microsoft.com/office/powerpoint/2012/main"/>
+      <p15:sldGuideLst xmlns:p15="http://schemas.microsoft.com/office/powerpoint/2012/main">
+        <p15:guide id="1" pos="325" userDrawn="1">
+          <p15:clr>
+            <a:srgbClr val="A4A3A4"/>
+          </p15:clr>
+        </p15:guide>
+        <p15:guide id="2" orient="horz" pos="3952" userDrawn="1">
+          <p15:clr>
+            <a:srgbClr val="A4A3A4"/>
+          </p15:clr>
+        </p15:guide>
+        <p15:guide id="3" orient="horz" pos="527" userDrawn="1">
+          <p15:clr>
+            <a:srgbClr val="A4A3A4"/>
+          </p15:clr>
+        </p15:guide>
+        <p15:guide id="4" pos="7355" userDrawn="1">
+          <p15:clr>
+            <a:srgbClr val="A4A3A4"/>
+          </p15:clr>
+        </p15:guide>
+        <p15:guide id="5" orient="horz" pos="935" userDrawn="1">
+          <p15:clr>
+            <a:srgbClr val="A4A3A4"/>
+          </p15:clr>
+        </p15:guide>
+        <p15:guide id="6" orient="horz" pos="1593" userDrawn="1">
+          <p15:clr>
+            <a:srgbClr val="A4A3A4"/>
+          </p15:clr>
+        </p15:guide>
+        <p15:guide id="7" pos="3749" userDrawn="1">
+          <p15:clr>
+            <a:srgbClr val="A4A3A4"/>
+          </p15:clr>
+        </p15:guide>
+        <p15:guide id="8" pos="3636" userDrawn="1">
+          <p15:clr>
+            <a:srgbClr val="A4A3A4"/>
+          </p15:clr>
+        </p15:guide>
+        <p15:guide id="9" orient="horz" pos="459" userDrawn="1">
+          <p15:clr>
+            <a:srgbClr val="A4A3A4"/>
+          </p15:clr>
+        </p15:guide>
+      </p15:sldGuideLst>
     </p:ext>
   </p:extLst>
 </p:presentation>
@@ -135,9 +181,7 @@
 <file path=ppt/revisionInfo.xml><?xml version="1.0" encoding="utf-8"?>
 <p1510:revInfo xmlns:a="http://schemas.openxmlformats.org/drawingml/2006/main" xmlns:r="http://schemas.openxmlformats.org/officeDocument/2006/relationships" xmlns:p1510="http://schemas.microsoft.com/office/powerpoint/2015/10/main">
   <p1510:revLst>
-    <p1510:client id="{86054CA9-01D5-41CB-9B3F-27FCE37911FD}" v="241" dt="2026-02-12T11:55:40.765"/>
-    <p1510:client id="{A4746134-D35D-467F-97F1-5867D8238A0A}" v="1" dt="2026-02-12T13:47:38.178"/>
-    <p1510:client id="{A75006E1-12E4-4211-AA72-F017A1B3EA92}" v="12" dt="2026-02-12T16:13:21.687"/>
+    <p1510:client id="{FCC558EA-3B58-450A-9CB5-4757D05055A0}" v="1" dt="2026-07-13T12:00:42.087"/>
   </p1510:revLst>
 </p1510:revInfo>
 </file>
@@ -147,1232 +191,22 @@
   <pc:docChgLst>
     <pc:chgData name="diagramador@aprovasim.com" userId="08c27f4fd777aeb1" providerId="LiveId" clId="{6DA82D89-F719-4B18-ABAA-0D43E56AF532}"/>
     <pc:docChg chg="undo custSel addSld delSld modSld sldOrd">
-      <pc:chgData name="diagramador@aprovasim.com" userId="08c27f4fd777aeb1" providerId="LiveId" clId="{6DA82D89-F719-4B18-ABAA-0D43E56AF532}" dt="2026-02-12T16:13:21.671" v="4525" actId="732"/>
+      <pc:chgData name="diagramador@aprovasim.com" userId="08c27f4fd777aeb1" providerId="LiveId" clId="{6DA82D89-F719-4B18-ABAA-0D43E56AF532}" dt="2026-07-13T12:00:42.072" v="4953" actId="108"/>
       <pc:docMkLst>
         <pc:docMk/>
       </pc:docMkLst>
-      <pc:sldChg chg="addSp delSp modSp del mod">
-        <pc:chgData name="diagramador@aprovasim.com" userId="08c27f4fd777aeb1" providerId="LiveId" clId="{6DA82D89-F719-4B18-ABAA-0D43E56AF532}" dt="2026-02-11T19:58:15.436" v="4241" actId="47"/>
+      <pc:sldChg chg="modSp">
+        <pc:chgData name="diagramador@aprovasim.com" userId="08c27f4fd777aeb1" providerId="LiveId" clId="{6DA82D89-F719-4B18-ABAA-0D43E56AF532}" dt="2026-07-13T12:00:42.072" v="4953" actId="108"/>
         <pc:sldMkLst>
           <pc:docMk/>
-          <pc:sldMk cId="3187768275" sldId="293"/>
+          <pc:sldMk cId="2235558883" sldId="728"/>
         </pc:sldMkLst>
-      </pc:sldChg>
-      <pc:sldChg chg="modSp mod">
-        <pc:chgData name="diagramador@aprovasim.com" userId="08c27f4fd777aeb1" providerId="LiveId" clId="{6DA82D89-F719-4B18-ABAA-0D43E56AF532}" dt="2026-02-11T20:57:25.303" v="4426" actId="404"/>
-        <pc:sldMkLst>
-          <pc:docMk/>
-          <pc:sldMk cId="3895221387" sldId="317"/>
-        </pc:sldMkLst>
-        <pc:spChg chg="mod">
-          <ac:chgData name="diagramador@aprovasim.com" userId="08c27f4fd777aeb1" providerId="LiveId" clId="{6DA82D89-F719-4B18-ABAA-0D43E56AF532}" dt="2026-02-11T20:57:25.303" v="4426" actId="404"/>
-          <ac:spMkLst>
-            <pc:docMk/>
-            <pc:sldMk cId="3895221387" sldId="317"/>
-            <ac:spMk id="4" creationId="{2AD2F24B-E9D7-CBE7-680B-3EE782AAC795}"/>
-          </ac:spMkLst>
-        </pc:spChg>
-      </pc:sldChg>
-      <pc:sldChg chg="addSp delSp modSp del mod">
-        <pc:chgData name="diagramador@aprovasim.com" userId="08c27f4fd777aeb1" providerId="LiveId" clId="{6DA82D89-F719-4B18-ABAA-0D43E56AF532}" dt="2026-02-11T19:58:15.436" v="4241" actId="47"/>
-        <pc:sldMkLst>
-          <pc:docMk/>
-          <pc:sldMk cId="1628923420" sldId="357"/>
-        </pc:sldMkLst>
-      </pc:sldChg>
-      <pc:sldChg chg="addSp delSp modSp mod">
-        <pc:chgData name="diagramador@aprovasim.com" userId="08c27f4fd777aeb1" providerId="LiveId" clId="{6DA82D89-F719-4B18-ABAA-0D43E56AF532}" dt="2026-02-11T20:01:46.284" v="4264" actId="732"/>
-        <pc:sldMkLst>
-          <pc:docMk/>
-          <pc:sldMk cId="3135647419" sldId="399"/>
-        </pc:sldMkLst>
-        <pc:spChg chg="mod">
-          <ac:chgData name="diagramador@aprovasim.com" userId="08c27f4fd777aeb1" providerId="LiveId" clId="{6DA82D89-F719-4B18-ABAA-0D43E56AF532}" dt="2026-02-11T19:31:58.127" v="3996" actId="255"/>
-          <ac:spMkLst>
-            <pc:docMk/>
-            <pc:sldMk cId="3135647419" sldId="399"/>
-            <ac:spMk id="5" creationId="{B4B2FEBD-4E9D-8C39-EB4B-0036615AA129}"/>
-          </ac:spMkLst>
-        </pc:spChg>
-        <pc:spChg chg="mod">
-          <ac:chgData name="diagramador@aprovasim.com" userId="08c27f4fd777aeb1" providerId="LiveId" clId="{6DA82D89-F719-4B18-ABAA-0D43E56AF532}" dt="2026-02-11T19:32:48.489" v="4001" actId="14100"/>
-          <ac:spMkLst>
-            <pc:docMk/>
-            <pc:sldMk cId="3135647419" sldId="399"/>
-            <ac:spMk id="6" creationId="{00000000-0000-0000-0000-000000000000}"/>
-          </ac:spMkLst>
-        </pc:spChg>
-        <pc:picChg chg="add del mod">
-          <ac:chgData name="diagramador@aprovasim.com" userId="08c27f4fd777aeb1" providerId="LiveId" clId="{6DA82D89-F719-4B18-ABAA-0D43E56AF532}" dt="2026-02-11T20:00:11.073" v="4246" actId="478"/>
+        <pc:picChg chg="mod">
+          <ac:chgData name="diagramador@aprovasim.com" userId="08c27f4fd777aeb1" providerId="LiveId" clId="{6DA82D89-F719-4B18-ABAA-0D43E56AF532}" dt="2026-07-13T12:00:42.072" v="4953" actId="108"/>
           <ac:picMkLst>
             <pc:docMk/>
-            <pc:sldMk cId="3135647419" sldId="399"/>
-            <ac:picMk id="3" creationId="{35D64BE2-DCA5-0BDD-57F3-DB6C1FB0FB3F}"/>
-          </ac:picMkLst>
-        </pc:picChg>
-        <pc:picChg chg="add del mod">
-          <ac:chgData name="diagramador@aprovasim.com" userId="08c27f4fd777aeb1" providerId="LiveId" clId="{6DA82D89-F719-4B18-ABAA-0D43E56AF532}" dt="2026-02-11T19:32:53.394" v="4002" actId="478"/>
-          <ac:picMkLst>
-            <pc:docMk/>
-            <pc:sldMk cId="3135647419" sldId="399"/>
-            <ac:picMk id="1026" creationId="{BAD8D5D8-B40B-C3D1-81D2-EF78B8EB8BB1}"/>
-          </ac:picMkLst>
-        </pc:picChg>
-        <pc:picChg chg="add del mod">
-          <ac:chgData name="diagramador@aprovasim.com" userId="08c27f4fd777aeb1" providerId="LiveId" clId="{6DA82D89-F719-4B18-ABAA-0D43E56AF532}" dt="2026-02-11T20:00:35.855" v="4251" actId="478"/>
-          <ac:picMkLst>
-            <pc:docMk/>
-            <pc:sldMk cId="3135647419" sldId="399"/>
-            <ac:picMk id="1028" creationId="{65F139C9-01E9-8271-C1D6-8DE4E3E33992}"/>
-          </ac:picMkLst>
-        </pc:picChg>
-        <pc:picChg chg="add del mod">
-          <ac:chgData name="diagramador@aprovasim.com" userId="08c27f4fd777aeb1" providerId="LiveId" clId="{6DA82D89-F719-4B18-ABAA-0D43E56AF532}" dt="2026-02-11T20:01:10.754" v="4257" actId="478"/>
-          <ac:picMkLst>
-            <pc:docMk/>
-            <pc:sldMk cId="3135647419" sldId="399"/>
-            <ac:picMk id="1030" creationId="{B3F26E68-6FC6-F8FB-5FDB-B28393F86F03}"/>
-          </ac:picMkLst>
-        </pc:picChg>
-        <pc:picChg chg="add mod">
-          <ac:chgData name="diagramador@aprovasim.com" userId="08c27f4fd777aeb1" providerId="LiveId" clId="{6DA82D89-F719-4B18-ABAA-0D43E56AF532}" dt="2026-02-11T20:01:46.284" v="4264" actId="732"/>
-          <ac:picMkLst>
-            <pc:docMk/>
-            <pc:sldMk cId="3135647419" sldId="399"/>
-            <ac:picMk id="1032" creationId="{9EBE76AE-9BB9-0144-25FC-B89F0079E388}"/>
-          </ac:picMkLst>
-        </pc:picChg>
-      </pc:sldChg>
-      <pc:sldChg chg="addSp delSp modSp del mod">
-        <pc:chgData name="diagramador@aprovasim.com" userId="08c27f4fd777aeb1" providerId="LiveId" clId="{6DA82D89-F719-4B18-ABAA-0D43E56AF532}" dt="2026-02-11T19:58:15.436" v="4241" actId="47"/>
-        <pc:sldMkLst>
-          <pc:docMk/>
-          <pc:sldMk cId="3095092524" sldId="560"/>
-        </pc:sldMkLst>
-      </pc:sldChg>
-      <pc:sldChg chg="addSp delSp modSp mod">
-        <pc:chgData name="diagramador@aprovasim.com" userId="08c27f4fd777aeb1" providerId="LiveId" clId="{6DA82D89-F719-4B18-ABAA-0D43E56AF532}" dt="2026-02-12T11:55:40.762" v="4454" actId="732"/>
-        <pc:sldMkLst>
-          <pc:docMk/>
-          <pc:sldMk cId="3142233136" sldId="575"/>
-        </pc:sldMkLst>
-        <pc:spChg chg="mod">
-          <ac:chgData name="diagramador@aprovasim.com" userId="08c27f4fd777aeb1" providerId="LiveId" clId="{6DA82D89-F719-4B18-ABAA-0D43E56AF532}" dt="2026-02-11T19:36:45.321" v="4048" actId="255"/>
-          <ac:spMkLst>
-            <pc:docMk/>
-            <pc:sldMk cId="3142233136" sldId="575"/>
-            <ac:spMk id="5" creationId="{3021CF2E-AB26-8412-AC83-54226DE2C55A}"/>
-          </ac:spMkLst>
-        </pc:spChg>
-        <pc:spChg chg="mod">
-          <ac:chgData name="diagramador@aprovasim.com" userId="08c27f4fd777aeb1" providerId="LiveId" clId="{6DA82D89-F719-4B18-ABAA-0D43E56AF532}" dt="2026-02-11T19:38:08.298" v="4058" actId="14100"/>
-          <ac:spMkLst>
-            <pc:docMk/>
-            <pc:sldMk cId="3142233136" sldId="575"/>
-            <ac:spMk id="6" creationId="{625F8C89-10CD-25D2-F470-5F5D5F2B69F2}"/>
-          </ac:spMkLst>
-        </pc:spChg>
-        <pc:picChg chg="add del mod">
-          <ac:chgData name="diagramador@aprovasim.com" userId="08c27f4fd777aeb1" providerId="LiveId" clId="{6DA82D89-F719-4B18-ABAA-0D43E56AF532}" dt="2026-02-12T11:53:33.969" v="4446" actId="478"/>
-          <ac:picMkLst>
-            <pc:docMk/>
-            <pc:sldMk cId="3142233136" sldId="575"/>
-            <ac:picMk id="2050" creationId="{311AA253-F174-F17E-E91A-2F81EF01F217}"/>
-          </ac:picMkLst>
-        </pc:picChg>
-        <pc:picChg chg="add mod">
-          <ac:chgData name="diagramador@aprovasim.com" userId="08c27f4fd777aeb1" providerId="LiveId" clId="{6DA82D89-F719-4B18-ABAA-0D43E56AF532}" dt="2026-02-12T11:55:40.762" v="4454" actId="732"/>
-          <ac:picMkLst>
-            <pc:docMk/>
-            <pc:sldMk cId="3142233136" sldId="575"/>
-            <ac:picMk id="2052" creationId="{CF20364A-4BC9-E790-B9B2-E9A4E7E2D83C}"/>
-          </ac:picMkLst>
-        </pc:picChg>
-        <pc:picChg chg="add del mod">
-          <ac:chgData name="diagramador@aprovasim.com" userId="08c27f4fd777aeb1" providerId="LiveId" clId="{6DA82D89-F719-4B18-ABAA-0D43E56AF532}" dt="2026-02-11T19:36:30.075" v="4045" actId="478"/>
-          <ac:picMkLst>
-            <pc:docMk/>
-            <pc:sldMk cId="3142233136" sldId="575"/>
-            <ac:picMk id="8194" creationId="{D3489572-97DC-8611-F4CB-0494D9E51342}"/>
-          </ac:picMkLst>
-        </pc:picChg>
-      </pc:sldChg>
-      <pc:sldChg chg="addSp delSp modSp mod">
-        <pc:chgData name="diagramador@aprovasim.com" userId="08c27f4fd777aeb1" providerId="LiveId" clId="{6DA82D89-F719-4B18-ABAA-0D43E56AF532}" dt="2026-02-11T20:03:15.973" v="4270" actId="732"/>
-        <pc:sldMkLst>
-          <pc:docMk/>
-          <pc:sldMk cId="1999350397" sldId="599"/>
-        </pc:sldMkLst>
-        <pc:spChg chg="mod">
-          <ac:chgData name="diagramador@aprovasim.com" userId="08c27f4fd777aeb1" providerId="LiveId" clId="{6DA82D89-F719-4B18-ABAA-0D43E56AF532}" dt="2026-02-11T19:33:12.010" v="4006" actId="255"/>
-          <ac:spMkLst>
-            <pc:docMk/>
-            <pc:sldMk cId="1999350397" sldId="599"/>
-            <ac:spMk id="5" creationId="{A51601C8-A419-43E8-27FA-C8417B406F14}"/>
-          </ac:spMkLst>
-        </pc:spChg>
-        <pc:spChg chg="mod">
-          <ac:chgData name="diagramador@aprovasim.com" userId="08c27f4fd777aeb1" providerId="LiveId" clId="{6DA82D89-F719-4B18-ABAA-0D43E56AF532}" dt="2026-02-11T19:33:26.809" v="4008" actId="14100"/>
-          <ac:spMkLst>
-            <pc:docMk/>
-            <pc:sldMk cId="1999350397" sldId="599"/>
-            <ac:spMk id="6" creationId="{46FC4CE2-33E5-6D0F-F849-E8AEF23B4B2F}"/>
-          </ac:spMkLst>
-        </pc:spChg>
-        <pc:spChg chg="add del">
-          <ac:chgData name="diagramador@aprovasim.com" userId="08c27f4fd777aeb1" providerId="LiveId" clId="{6DA82D89-F719-4B18-ABAA-0D43E56AF532}" dt="2026-02-11T19:33:29.823" v="4012"/>
-          <ac:spMkLst>
-            <pc:docMk/>
-            <pc:sldMk cId="1999350397" sldId="599"/>
-            <ac:spMk id="7" creationId="{B47DD127-AFB5-B66B-12EB-427E03A8F551}"/>
-          </ac:spMkLst>
-        </pc:spChg>
-        <pc:picChg chg="add del mod">
-          <ac:chgData name="diagramador@aprovasim.com" userId="08c27f4fd777aeb1" providerId="LiveId" clId="{6DA82D89-F719-4B18-ABAA-0D43E56AF532}" dt="2026-02-11T19:33:31.885" v="4013" actId="478"/>
-          <ac:picMkLst>
-            <pc:docMk/>
-            <pc:sldMk cId="1999350397" sldId="599"/>
-            <ac:picMk id="3" creationId="{4BBFF9D2-39D6-3B0B-EAA6-AB35AF9363AA}"/>
-          </ac:picMkLst>
-        </pc:picChg>
-        <pc:picChg chg="add mod">
-          <ac:chgData name="diagramador@aprovasim.com" userId="08c27f4fd777aeb1" providerId="LiveId" clId="{6DA82D89-F719-4B18-ABAA-0D43E56AF532}" dt="2026-02-11T20:03:15.973" v="4270" actId="732"/>
-          <ac:picMkLst>
-            <pc:docMk/>
-            <pc:sldMk cId="1999350397" sldId="599"/>
-            <ac:picMk id="2050" creationId="{2230275F-1ACF-751F-1D2C-9E6505AE9EFF}"/>
-          </ac:picMkLst>
-        </pc:picChg>
-      </pc:sldChg>
-      <pc:sldChg chg="addSp delSp modSp mod">
-        <pc:chgData name="diagramador@aprovasim.com" userId="08c27f4fd777aeb1" providerId="LiveId" clId="{6DA82D89-F719-4B18-ABAA-0D43E56AF532}" dt="2026-02-11T20:06:48.528" v="4287" actId="732"/>
-        <pc:sldMkLst>
-          <pc:docMk/>
-          <pc:sldMk cId="592009383" sldId="600"/>
-        </pc:sldMkLst>
-        <pc:spChg chg="mod">
-          <ac:chgData name="diagramador@aprovasim.com" userId="08c27f4fd777aeb1" providerId="LiveId" clId="{6DA82D89-F719-4B18-ABAA-0D43E56AF532}" dt="2026-02-11T19:35:04.896" v="4031" actId="14100"/>
-          <ac:spMkLst>
-            <pc:docMk/>
-            <pc:sldMk cId="592009383" sldId="600"/>
-            <ac:spMk id="5" creationId="{81DBA1E5-B334-9A55-1165-E60ACE75BFDC}"/>
-          </ac:spMkLst>
-        </pc:spChg>
-        <pc:spChg chg="mod">
-          <ac:chgData name="diagramador@aprovasim.com" userId="08c27f4fd777aeb1" providerId="LiveId" clId="{6DA82D89-F719-4B18-ABAA-0D43E56AF532}" dt="2026-02-11T19:35:12.622" v="4032"/>
-          <ac:spMkLst>
-            <pc:docMk/>
-            <pc:sldMk cId="592009383" sldId="600"/>
-            <ac:spMk id="6" creationId="{6FCA1E11-0A1E-188A-AAEC-74A79C004076}"/>
-          </ac:spMkLst>
-        </pc:spChg>
-        <pc:picChg chg="add mod">
-          <ac:chgData name="diagramador@aprovasim.com" userId="08c27f4fd777aeb1" providerId="LiveId" clId="{6DA82D89-F719-4B18-ABAA-0D43E56AF532}" dt="2026-02-11T20:06:48.528" v="4287" actId="732"/>
-          <ac:picMkLst>
-            <pc:docMk/>
-            <pc:sldMk cId="592009383" sldId="600"/>
-            <ac:picMk id="5122" creationId="{6CA6846E-EFFA-79C5-571C-CAC9EE050007}"/>
-          </ac:picMkLst>
-        </pc:picChg>
-        <pc:picChg chg="add del mod">
-          <ac:chgData name="diagramador@aprovasim.com" userId="08c27f4fd777aeb1" providerId="LiveId" clId="{6DA82D89-F719-4B18-ABAA-0D43E56AF532}" dt="2026-02-11T19:35:21.888" v="4033" actId="478"/>
-          <ac:picMkLst>
-            <pc:docMk/>
-            <pc:sldMk cId="592009383" sldId="600"/>
-            <ac:picMk id="6150" creationId="{3DDD7C38-CF11-C971-5410-55993C3226C0}"/>
-          </ac:picMkLst>
-        </pc:picChg>
-      </pc:sldChg>
-      <pc:sldChg chg="addSp delSp modSp mod">
-        <pc:chgData name="diagramador@aprovasim.com" userId="08c27f4fd777aeb1" providerId="LiveId" clId="{6DA82D89-F719-4B18-ABAA-0D43E56AF532}" dt="2026-02-11T20:05:34.606" v="4280" actId="732"/>
-        <pc:sldMkLst>
-          <pc:docMk/>
-          <pc:sldMk cId="2722270705" sldId="601"/>
-        </pc:sldMkLst>
-        <pc:spChg chg="add mod">
-          <ac:chgData name="diagramador@aprovasim.com" userId="08c27f4fd777aeb1" providerId="LiveId" clId="{6DA82D89-F719-4B18-ABAA-0D43E56AF532}" dt="2026-02-11T19:53:39.899" v="4192" actId="1036"/>
-          <ac:spMkLst>
-            <pc:docMk/>
-            <pc:sldMk cId="2722270705" sldId="601"/>
-            <ac:spMk id="3" creationId="{843F1A6B-3D30-AF9B-1308-E02B92942FAB}"/>
-          </ac:spMkLst>
-        </pc:spChg>
-        <pc:spChg chg="add del mod">
-          <ac:chgData name="diagramador@aprovasim.com" userId="08c27f4fd777aeb1" providerId="LiveId" clId="{6DA82D89-F719-4B18-ABAA-0D43E56AF532}" dt="2026-02-11T19:53:32.985" v="4187" actId="478"/>
-          <ac:spMkLst>
-            <pc:docMk/>
-            <pc:sldMk cId="2722270705" sldId="601"/>
-            <ac:spMk id="4" creationId="{DA502DA2-9B77-01F7-ECA9-34F2C5D32DA2}"/>
-          </ac:spMkLst>
-        </pc:spChg>
-        <pc:spChg chg="mod">
-          <ac:chgData name="diagramador@aprovasim.com" userId="08c27f4fd777aeb1" providerId="LiveId" clId="{6DA82D89-F719-4B18-ABAA-0D43E56AF532}" dt="2026-02-11T19:52:19.164" v="4166" actId="1076"/>
-          <ac:spMkLst>
-            <pc:docMk/>
-            <pc:sldMk cId="2722270705" sldId="601"/>
-            <ac:spMk id="5" creationId="{F30F1BDC-9371-1A04-7191-A6E77342FD6B}"/>
-          </ac:spMkLst>
-        </pc:spChg>
-        <pc:spChg chg="mod">
-          <ac:chgData name="diagramador@aprovasim.com" userId="08c27f4fd777aeb1" providerId="LiveId" clId="{6DA82D89-F719-4B18-ABAA-0D43E56AF532}" dt="2026-02-11T19:53:48.875" v="4193" actId="14100"/>
-          <ac:spMkLst>
-            <pc:docMk/>
-            <pc:sldMk cId="2722270705" sldId="601"/>
-            <ac:spMk id="6" creationId="{88468659-EB21-4631-8A37-B96867A50CEA}"/>
-          </ac:spMkLst>
-        </pc:spChg>
-        <pc:picChg chg="add mod">
-          <ac:chgData name="diagramador@aprovasim.com" userId="08c27f4fd777aeb1" providerId="LiveId" clId="{6DA82D89-F719-4B18-ABAA-0D43E56AF532}" dt="2026-02-11T20:05:34.606" v="4280" actId="732"/>
-          <ac:picMkLst>
-            <pc:docMk/>
-            <pc:sldMk cId="2722270705" sldId="601"/>
-            <ac:picMk id="4098" creationId="{6F591E15-B633-3E07-8A75-863256A5DAB7}"/>
-          </ac:picMkLst>
-        </pc:picChg>
-        <pc:picChg chg="add del mod">
-          <ac:chgData name="diagramador@aprovasim.com" userId="08c27f4fd777aeb1" providerId="LiveId" clId="{6DA82D89-F719-4B18-ABAA-0D43E56AF532}" dt="2026-02-11T19:34:22.684" v="4021" actId="478"/>
-          <ac:picMkLst>
-            <pc:docMk/>
-            <pc:sldMk cId="2722270705" sldId="601"/>
-            <ac:picMk id="4100" creationId="{2D2B515D-06CC-F23A-66DD-81828E18ADDE}"/>
-          </ac:picMkLst>
-        </pc:picChg>
-      </pc:sldChg>
-      <pc:sldChg chg="addSp delSp modSp del mod">
-        <pc:chgData name="diagramador@aprovasim.com" userId="08c27f4fd777aeb1" providerId="LiveId" clId="{6DA82D89-F719-4B18-ABAA-0D43E56AF532}" dt="2026-02-11T19:58:15.436" v="4241" actId="47"/>
-        <pc:sldMkLst>
-          <pc:docMk/>
-          <pc:sldMk cId="1607274927" sldId="602"/>
-        </pc:sldMkLst>
-      </pc:sldChg>
-      <pc:sldChg chg="addSp delSp modSp mod">
-        <pc:chgData name="diagramador@aprovasim.com" userId="08c27f4fd777aeb1" providerId="LiveId" clId="{6DA82D89-F719-4B18-ABAA-0D43E56AF532}" dt="2026-02-11T20:19:08.617" v="4297" actId="732"/>
-        <pc:sldMkLst>
-          <pc:docMk/>
-          <pc:sldMk cId="2566922897" sldId="607"/>
-        </pc:sldMkLst>
-        <pc:spChg chg="mod">
-          <ac:chgData name="diagramador@aprovasim.com" userId="08c27f4fd777aeb1" providerId="LiveId" clId="{6DA82D89-F719-4B18-ABAA-0D43E56AF532}" dt="2026-02-11T19:39:13.028" v="4072" actId="14100"/>
-          <ac:spMkLst>
-            <pc:docMk/>
-            <pc:sldMk cId="2566922897" sldId="607"/>
-            <ac:spMk id="5" creationId="{8DD09886-F90F-E9A0-914F-C4C8FD23C48A}"/>
-          </ac:spMkLst>
-        </pc:spChg>
-        <pc:spChg chg="mod">
-          <ac:chgData name="diagramador@aprovasim.com" userId="08c27f4fd777aeb1" providerId="LiveId" clId="{6DA82D89-F719-4B18-ABAA-0D43E56AF532}" dt="2026-02-11T19:39:26.614" v="4074" actId="14100"/>
-          <ac:spMkLst>
-            <pc:docMk/>
-            <pc:sldMk cId="2566922897" sldId="607"/>
-            <ac:spMk id="6" creationId="{55D1643D-6000-D738-564A-365D27CFE068}"/>
-          </ac:spMkLst>
-        </pc:spChg>
-        <pc:picChg chg="add mod">
-          <ac:chgData name="diagramador@aprovasim.com" userId="08c27f4fd777aeb1" providerId="LiveId" clId="{6DA82D89-F719-4B18-ABAA-0D43E56AF532}" dt="2026-02-11T20:19:08.617" v="4297" actId="732"/>
-          <ac:picMkLst>
-            <pc:docMk/>
-            <pc:sldMk cId="2566922897" sldId="607"/>
-            <ac:picMk id="7170" creationId="{6DAC3E23-B73A-18C1-3576-B247887CBF39}"/>
-          </ac:picMkLst>
-        </pc:picChg>
-        <pc:picChg chg="add del mod">
-          <ac:chgData name="diagramador@aprovasim.com" userId="08c27f4fd777aeb1" providerId="LiveId" clId="{6DA82D89-F719-4B18-ABAA-0D43E56AF532}" dt="2026-02-11T19:39:30.863" v="4075" actId="478"/>
-          <ac:picMkLst>
-            <pc:docMk/>
-            <pc:sldMk cId="2566922897" sldId="607"/>
-            <ac:picMk id="10244" creationId="{9E110E8B-14A8-352C-26CE-421E09C1020E}"/>
-          </ac:picMkLst>
-        </pc:picChg>
-      </pc:sldChg>
-      <pc:sldChg chg="addSp delSp modSp mod">
-        <pc:chgData name="diagramador@aprovasim.com" userId="08c27f4fd777aeb1" providerId="LiveId" clId="{6DA82D89-F719-4B18-ABAA-0D43E56AF532}" dt="2026-02-11T20:24:28.367" v="4314" actId="732"/>
-        <pc:sldMkLst>
-          <pc:docMk/>
-          <pc:sldMk cId="2274074053" sldId="611"/>
-        </pc:sldMkLst>
-        <pc:spChg chg="mod">
-          <ac:chgData name="diagramador@aprovasim.com" userId="08c27f4fd777aeb1" providerId="LiveId" clId="{6DA82D89-F719-4B18-ABAA-0D43E56AF532}" dt="2026-02-11T19:40:54.593" v="4091" actId="14100"/>
-          <ac:spMkLst>
-            <pc:docMk/>
-            <pc:sldMk cId="2274074053" sldId="611"/>
-            <ac:spMk id="5" creationId="{B5CF3A89-A775-874C-199C-6CA979BD9BB2}"/>
-          </ac:spMkLst>
-        </pc:spChg>
-        <pc:spChg chg="mod">
-          <ac:chgData name="diagramador@aprovasim.com" userId="08c27f4fd777aeb1" providerId="LiveId" clId="{6DA82D89-F719-4B18-ABAA-0D43E56AF532}" dt="2026-02-11T19:41:06.748" v="4093" actId="14100"/>
-          <ac:spMkLst>
-            <pc:docMk/>
-            <pc:sldMk cId="2274074053" sldId="611"/>
-            <ac:spMk id="6" creationId="{C3B3B0B7-468F-93D7-5285-748FECFFED54}"/>
-          </ac:spMkLst>
-        </pc:spChg>
-        <pc:picChg chg="add del">
-          <ac:chgData name="diagramador@aprovasim.com" userId="08c27f4fd777aeb1" providerId="LiveId" clId="{6DA82D89-F719-4B18-ABAA-0D43E56AF532}" dt="2026-02-11T20:22:41.207" v="4304" actId="478"/>
-          <ac:picMkLst>
-            <pc:docMk/>
-            <pc:sldMk cId="2274074053" sldId="611"/>
-            <ac:picMk id="9218" creationId="{017E66B9-C795-1DB4-40A2-0C517C9FD79E}"/>
-          </ac:picMkLst>
-        </pc:picChg>
-        <pc:picChg chg="add del mod">
-          <ac:chgData name="diagramador@aprovasim.com" userId="08c27f4fd777aeb1" providerId="LiveId" clId="{6DA82D89-F719-4B18-ABAA-0D43E56AF532}" dt="2026-02-11T20:24:17.069" v="4310" actId="478"/>
-          <ac:picMkLst>
-            <pc:docMk/>
-            <pc:sldMk cId="2274074053" sldId="611"/>
-            <ac:picMk id="9220" creationId="{731D61A3-E737-D11B-432F-96C9B1C420E7}"/>
-          </ac:picMkLst>
-        </pc:picChg>
-        <pc:picChg chg="add mod">
-          <ac:chgData name="diagramador@aprovasim.com" userId="08c27f4fd777aeb1" providerId="LiveId" clId="{6DA82D89-F719-4B18-ABAA-0D43E56AF532}" dt="2026-02-11T20:24:28.367" v="4314" actId="732"/>
-          <ac:picMkLst>
-            <pc:docMk/>
-            <pc:sldMk cId="2274074053" sldId="611"/>
-            <ac:picMk id="9222" creationId="{BB8731DA-1D89-26F5-A87C-2D406C415D70}"/>
-          </ac:picMkLst>
-        </pc:picChg>
-        <pc:picChg chg="add del mod">
-          <ac:chgData name="diagramador@aprovasim.com" userId="08c27f4fd777aeb1" providerId="LiveId" clId="{6DA82D89-F719-4B18-ABAA-0D43E56AF532}" dt="2026-02-11T19:40:36.615" v="4086" actId="478"/>
-          <ac:picMkLst>
-            <pc:docMk/>
-            <pc:sldMk cId="2274074053" sldId="611"/>
-            <ac:picMk id="12290" creationId="{00A943A6-C636-6146-1C72-A8018451AD98}"/>
-          </ac:picMkLst>
-        </pc:picChg>
-      </pc:sldChg>
-      <pc:sldChg chg="addSp delSp modSp mod">
-        <pc:chgData name="diagramador@aprovasim.com" userId="08c27f4fd777aeb1" providerId="LiveId" clId="{6DA82D89-F719-4B18-ABAA-0D43E56AF532}" dt="2026-02-11T20:29:43.245" v="4325" actId="732"/>
-        <pc:sldMkLst>
-          <pc:docMk/>
-          <pc:sldMk cId="2041764478" sldId="612"/>
-        </pc:sldMkLst>
-        <pc:spChg chg="mod">
-          <ac:chgData name="diagramador@aprovasim.com" userId="08c27f4fd777aeb1" providerId="LiveId" clId="{6DA82D89-F719-4B18-ABAA-0D43E56AF532}" dt="2026-02-11T19:42:14.866" v="4106" actId="14100"/>
-          <ac:spMkLst>
-            <pc:docMk/>
-            <pc:sldMk cId="2041764478" sldId="612"/>
-            <ac:spMk id="5" creationId="{52523CAD-43A7-4FF2-0CF0-E037EF3ED3A8}"/>
-          </ac:spMkLst>
-        </pc:spChg>
-        <pc:spChg chg="mod">
-          <ac:chgData name="diagramador@aprovasim.com" userId="08c27f4fd777aeb1" providerId="LiveId" clId="{6DA82D89-F719-4B18-ABAA-0D43E56AF532}" dt="2026-02-11T19:42:30.964" v="4109" actId="14100"/>
-          <ac:spMkLst>
-            <pc:docMk/>
-            <pc:sldMk cId="2041764478" sldId="612"/>
-            <ac:spMk id="6" creationId="{236E73FD-5CE9-F478-7FA2-BFEDB7F2FFFC}"/>
-          </ac:spMkLst>
-        </pc:spChg>
-        <pc:picChg chg="add mod">
-          <ac:chgData name="diagramador@aprovasim.com" userId="08c27f4fd777aeb1" providerId="LiveId" clId="{6DA82D89-F719-4B18-ABAA-0D43E56AF532}" dt="2026-02-11T20:29:43.245" v="4325" actId="732"/>
-          <ac:picMkLst>
-            <pc:docMk/>
-            <pc:sldMk cId="2041764478" sldId="612"/>
-            <ac:picMk id="11266" creationId="{4ED6AE63-13C7-D18F-194B-3106F016BADA}"/>
-          </ac:picMkLst>
-        </pc:picChg>
-        <pc:picChg chg="add del mod">
-          <ac:chgData name="diagramador@aprovasim.com" userId="08c27f4fd777aeb1" providerId="LiveId" clId="{6DA82D89-F719-4B18-ABAA-0D43E56AF532}" dt="2026-02-11T19:42:16.152" v="4107" actId="478"/>
-          <ac:picMkLst>
-            <pc:docMk/>
-            <pc:sldMk cId="2041764478" sldId="612"/>
-            <ac:picMk id="13314" creationId="{0931CD95-520A-1B76-D7FF-94BB79008C62}"/>
-          </ac:picMkLst>
-        </pc:picChg>
-      </pc:sldChg>
-      <pc:sldChg chg="addSp delSp modSp del mod">
-        <pc:chgData name="diagramador@aprovasim.com" userId="08c27f4fd777aeb1" providerId="LiveId" clId="{6DA82D89-F719-4B18-ABAA-0D43E56AF532}" dt="2026-02-11T19:58:15.436" v="4241" actId="47"/>
-        <pc:sldMkLst>
-          <pc:docMk/>
-          <pc:sldMk cId="3575631179" sldId="661"/>
-        </pc:sldMkLst>
-      </pc:sldChg>
-      <pc:sldChg chg="addSp delSp modSp del mod">
-        <pc:chgData name="diagramador@aprovasim.com" userId="08c27f4fd777aeb1" providerId="LiveId" clId="{6DA82D89-F719-4B18-ABAA-0D43E56AF532}" dt="2026-02-11T19:58:15.436" v="4241" actId="47"/>
-        <pc:sldMkLst>
-          <pc:docMk/>
-          <pc:sldMk cId="3946459515" sldId="662"/>
-        </pc:sldMkLst>
-      </pc:sldChg>
-      <pc:sldChg chg="addSp delSp modSp del mod">
-        <pc:chgData name="diagramador@aprovasim.com" userId="08c27f4fd777aeb1" providerId="LiveId" clId="{6DA82D89-F719-4B18-ABAA-0D43E56AF532}" dt="2026-02-11T19:58:15.436" v="4241" actId="47"/>
-        <pc:sldMkLst>
-          <pc:docMk/>
-          <pc:sldMk cId="4077549648" sldId="663"/>
-        </pc:sldMkLst>
-      </pc:sldChg>
-      <pc:sldChg chg="addSp delSp modSp del mod">
-        <pc:chgData name="diagramador@aprovasim.com" userId="08c27f4fd777aeb1" providerId="LiveId" clId="{6DA82D89-F719-4B18-ABAA-0D43E56AF532}" dt="2026-02-11T19:58:15.436" v="4241" actId="47"/>
-        <pc:sldMkLst>
-          <pc:docMk/>
-          <pc:sldMk cId="2812501063" sldId="670"/>
-        </pc:sldMkLst>
-      </pc:sldChg>
-      <pc:sldChg chg="addSp delSp modSp mod">
-        <pc:chgData name="diagramador@aprovasim.com" userId="08c27f4fd777aeb1" providerId="LiveId" clId="{6DA82D89-F719-4B18-ABAA-0D43E56AF532}" dt="2026-02-11T20:43:39.175" v="4366" actId="732"/>
-        <pc:sldMkLst>
-          <pc:docMk/>
-          <pc:sldMk cId="2426611101" sldId="674"/>
-        </pc:sldMkLst>
-        <pc:spChg chg="add mod">
-          <ac:chgData name="diagramador@aprovasim.com" userId="08c27f4fd777aeb1" providerId="LiveId" clId="{6DA82D89-F719-4B18-ABAA-0D43E56AF532}" dt="2026-02-11T19:56:40.864" v="4235" actId="1076"/>
-          <ac:spMkLst>
-            <pc:docMk/>
-            <pc:sldMk cId="2426611101" sldId="674"/>
-            <ac:spMk id="3" creationId="{B8C5C61C-4022-47D3-225D-AD3A7513F150}"/>
-          </ac:spMkLst>
-        </pc:spChg>
-        <pc:spChg chg="mod">
-          <ac:chgData name="diagramador@aprovasim.com" userId="08c27f4fd777aeb1" providerId="LiveId" clId="{6DA82D89-F719-4B18-ABAA-0D43E56AF532}" dt="2026-02-11T19:56:50.078" v="4236" actId="255"/>
-          <ac:spMkLst>
-            <pc:docMk/>
-            <pc:sldMk cId="2426611101" sldId="674"/>
-            <ac:spMk id="5" creationId="{41EBFCFA-F14A-61A9-648D-9BF93DF42CE8}"/>
-          </ac:spMkLst>
-        </pc:spChg>
-        <pc:spChg chg="mod">
-          <ac:chgData name="diagramador@aprovasim.com" userId="08c27f4fd777aeb1" providerId="LiveId" clId="{6DA82D89-F719-4B18-ABAA-0D43E56AF532}" dt="2026-02-11T19:56:18.705" v="4214" actId="1076"/>
-          <ac:spMkLst>
-            <pc:docMk/>
-            <pc:sldMk cId="2426611101" sldId="674"/>
-            <ac:spMk id="6" creationId="{9CF6F7C5-8944-386B-09E3-78C1861E4780}"/>
-          </ac:spMkLst>
-        </pc:spChg>
-        <pc:picChg chg="add del mod">
-          <ac:chgData name="diagramador@aprovasim.com" userId="08c27f4fd777aeb1" providerId="LiveId" clId="{6DA82D89-F719-4B18-ABAA-0D43E56AF532}" dt="2026-02-11T20:43:18.829" v="4360" actId="478"/>
-          <ac:picMkLst>
-            <pc:docMk/>
-            <pc:sldMk cId="2426611101" sldId="674"/>
-            <ac:picMk id="15362" creationId="{1D1CC6A4-4371-1CD1-9B85-B43055D2254E}"/>
-          </ac:picMkLst>
-        </pc:picChg>
-        <pc:picChg chg="add mod">
-          <ac:chgData name="diagramador@aprovasim.com" userId="08c27f4fd777aeb1" providerId="LiveId" clId="{6DA82D89-F719-4B18-ABAA-0D43E56AF532}" dt="2026-02-11T20:43:39.175" v="4366" actId="732"/>
-          <ac:picMkLst>
-            <pc:docMk/>
-            <pc:sldMk cId="2426611101" sldId="674"/>
-            <ac:picMk id="15364" creationId="{F4A91CB3-3EEF-1549-5571-DAF110E6777C}"/>
-          </ac:picMkLst>
-        </pc:picChg>
-        <pc:picChg chg="add del mod">
-          <ac:chgData name="diagramador@aprovasim.com" userId="08c27f4fd777aeb1" providerId="LiveId" clId="{6DA82D89-F719-4B18-ABAA-0D43E56AF532}" dt="2026-02-11T19:44:55.707" v="4137" actId="478"/>
-          <ac:picMkLst>
-            <pc:docMk/>
-            <pc:sldMk cId="2426611101" sldId="674"/>
-            <ac:picMk id="17410" creationId="{392F032A-EEC1-B934-1D6C-65B3A787C310}"/>
-          </ac:picMkLst>
-        </pc:picChg>
-      </pc:sldChg>
-      <pc:sldChg chg="addSp delSp modSp mod">
-        <pc:chgData name="diagramador@aprovasim.com" userId="08c27f4fd777aeb1" providerId="LiveId" clId="{6DA82D89-F719-4B18-ABAA-0D43E56AF532}" dt="2026-02-11T20:34:40.157" v="4339" actId="732"/>
-        <pc:sldMkLst>
-          <pc:docMk/>
-          <pc:sldMk cId="1053317214" sldId="675"/>
-        </pc:sldMkLst>
-        <pc:spChg chg="mod">
-          <ac:chgData name="diagramador@aprovasim.com" userId="08c27f4fd777aeb1" providerId="LiveId" clId="{6DA82D89-F719-4B18-ABAA-0D43E56AF532}" dt="2026-02-11T19:43:31.603" v="4120" actId="14100"/>
-          <ac:spMkLst>
-            <pc:docMk/>
-            <pc:sldMk cId="1053317214" sldId="675"/>
-            <ac:spMk id="5" creationId="{61642FED-6245-43AB-F1F6-2728225F7099}"/>
-          </ac:spMkLst>
-        </pc:spChg>
-        <pc:spChg chg="mod">
-          <ac:chgData name="diagramador@aprovasim.com" userId="08c27f4fd777aeb1" providerId="LiveId" clId="{6DA82D89-F719-4B18-ABAA-0D43E56AF532}" dt="2026-02-11T19:43:41.480" v="4122" actId="14100"/>
-          <ac:spMkLst>
-            <pc:docMk/>
-            <pc:sldMk cId="1053317214" sldId="675"/>
-            <ac:spMk id="6" creationId="{884B076F-1743-3441-69D9-C86BB941E628}"/>
-          </ac:spMkLst>
-        </pc:spChg>
-        <pc:picChg chg="add mod">
-          <ac:chgData name="diagramador@aprovasim.com" userId="08c27f4fd777aeb1" providerId="LiveId" clId="{6DA82D89-F719-4B18-ABAA-0D43E56AF532}" dt="2026-02-11T20:34:40.157" v="4339" actId="732"/>
-          <ac:picMkLst>
-            <pc:docMk/>
-            <pc:sldMk cId="1053317214" sldId="675"/>
-            <ac:picMk id="13314" creationId="{01C3DF56-9E86-0C14-CBAC-3711CEF27EAF}"/>
-          </ac:picMkLst>
-        </pc:picChg>
-        <pc:picChg chg="add del mod">
-          <ac:chgData name="diagramador@aprovasim.com" userId="08c27f4fd777aeb1" providerId="LiveId" clId="{6DA82D89-F719-4B18-ABAA-0D43E56AF532}" dt="2026-02-11T19:43:29.646" v="4119" actId="478"/>
-          <ac:picMkLst>
-            <pc:docMk/>
-            <pc:sldMk cId="1053317214" sldId="675"/>
-            <ac:picMk id="15362" creationId="{2F7AE15D-B144-F442-4A81-AEEAF29CC55A}"/>
-          </ac:picMkLst>
-        </pc:picChg>
-      </pc:sldChg>
-      <pc:sldChg chg="addSp delSp modSp del mod">
-        <pc:chgData name="diagramador@aprovasim.com" userId="08c27f4fd777aeb1" providerId="LiveId" clId="{6DA82D89-F719-4B18-ABAA-0D43E56AF532}" dt="2026-02-11T19:58:15.436" v="4241" actId="47"/>
-        <pc:sldMkLst>
-          <pc:docMk/>
-          <pc:sldMk cId="3836769148" sldId="678"/>
-        </pc:sldMkLst>
-      </pc:sldChg>
-      <pc:sldChg chg="addSp modSp add del mod">
-        <pc:chgData name="diagramador@aprovasim.com" userId="08c27f4fd777aeb1" providerId="LiveId" clId="{6DA82D89-F719-4B18-ABAA-0D43E56AF532}" dt="2026-02-11T19:32:55.384" v="4003" actId="47"/>
-        <pc:sldMkLst>
-          <pc:docMk/>
-          <pc:sldMk cId="1071212529" sldId="679"/>
-        </pc:sldMkLst>
-      </pc:sldChg>
-      <pc:sldChg chg="addSp delSp modSp add mod">
-        <pc:chgData name="diagramador@aprovasim.com" userId="08c27f4fd777aeb1" providerId="LiveId" clId="{6DA82D89-F719-4B18-ABAA-0D43E56AF532}" dt="2026-02-11T20:04:20.993" v="4275" actId="732"/>
-        <pc:sldMkLst>
-          <pc:docMk/>
-          <pc:sldMk cId="3264608165" sldId="680"/>
-        </pc:sldMkLst>
-        <pc:spChg chg="mod">
-          <ac:chgData name="diagramador@aprovasim.com" userId="08c27f4fd777aeb1" providerId="LiveId" clId="{6DA82D89-F719-4B18-ABAA-0D43E56AF532}" dt="2026-02-11T19:33:48.509" v="4017" actId="14100"/>
-          <ac:spMkLst>
-            <pc:docMk/>
-            <pc:sldMk cId="3264608165" sldId="680"/>
-            <ac:spMk id="5" creationId="{28939D0E-628B-1828-5C28-341254AA76AF}"/>
-          </ac:spMkLst>
-        </pc:spChg>
-        <pc:spChg chg="mod">
-          <ac:chgData name="diagramador@aprovasim.com" userId="08c27f4fd777aeb1" providerId="LiveId" clId="{6DA82D89-F719-4B18-ABAA-0D43E56AF532}" dt="2026-02-11T19:34:05.209" v="4019" actId="114"/>
-          <ac:spMkLst>
-            <pc:docMk/>
-            <pc:sldMk cId="3264608165" sldId="680"/>
-            <ac:spMk id="6" creationId="{333FBD04-A9FF-7FDB-9148-5FC39FB6E0BC}"/>
-          </ac:spMkLst>
-        </pc:spChg>
-        <pc:picChg chg="add del mod">
-          <ac:chgData name="diagramador@aprovasim.com" userId="08c27f4fd777aeb1" providerId="LiveId" clId="{6DA82D89-F719-4B18-ABAA-0D43E56AF532}" dt="2026-02-11T19:34:14.918" v="4020" actId="478"/>
-          <ac:picMkLst>
-            <pc:docMk/>
-            <pc:sldMk cId="3264608165" sldId="680"/>
-            <ac:picMk id="3" creationId="{0E515C9A-256D-D2A6-DFC2-748B523FC37A}"/>
-          </ac:picMkLst>
-        </pc:picChg>
-        <pc:picChg chg="add mod">
-          <ac:chgData name="diagramador@aprovasim.com" userId="08c27f4fd777aeb1" providerId="LiveId" clId="{6DA82D89-F719-4B18-ABAA-0D43E56AF532}" dt="2026-02-11T20:04:20.993" v="4275" actId="732"/>
-          <ac:picMkLst>
-            <pc:docMk/>
-            <pc:sldMk cId="3264608165" sldId="680"/>
-            <ac:picMk id="3074" creationId="{1EE32A8F-1A32-B238-DE50-0B57927B77BF}"/>
-          </ac:picMkLst>
-        </pc:picChg>
-      </pc:sldChg>
-      <pc:sldChg chg="addSp modSp add del mod">
-        <pc:chgData name="diagramador@aprovasim.com" userId="08c27f4fd777aeb1" providerId="LiveId" clId="{6DA82D89-F719-4B18-ABAA-0D43E56AF532}" dt="2026-02-11T19:34:48.096" v="4027" actId="47"/>
-        <pc:sldMkLst>
-          <pc:docMk/>
-          <pc:sldMk cId="3835665578" sldId="681"/>
-        </pc:sldMkLst>
-      </pc:sldChg>
-      <pc:sldChg chg="addSp delSp modSp add mod">
-        <pc:chgData name="diagramador@aprovasim.com" userId="08c27f4fd777aeb1" providerId="LiveId" clId="{6DA82D89-F719-4B18-ABAA-0D43E56AF532}" dt="2026-02-11T20:07:37.628" v="4292" actId="732"/>
-        <pc:sldMkLst>
-          <pc:docMk/>
-          <pc:sldMk cId="3732443723" sldId="682"/>
-        </pc:sldMkLst>
-        <pc:spChg chg="mod">
-          <ac:chgData name="diagramador@aprovasim.com" userId="08c27f4fd777aeb1" providerId="LiveId" clId="{6DA82D89-F719-4B18-ABAA-0D43E56AF532}" dt="2026-02-11T19:35:38.480" v="4037" actId="14100"/>
-          <ac:spMkLst>
-            <pc:docMk/>
-            <pc:sldMk cId="3732443723" sldId="682"/>
-            <ac:spMk id="5" creationId="{BCD811D3-4170-3624-77F9-399D15CB2919}"/>
-          </ac:spMkLst>
-        </pc:spChg>
-        <pc:spChg chg="mod">
-          <ac:chgData name="diagramador@aprovasim.com" userId="08c27f4fd777aeb1" providerId="LiveId" clId="{6DA82D89-F719-4B18-ABAA-0D43E56AF532}" dt="2026-02-11T19:36:22.208" v="4044" actId="14100"/>
-          <ac:spMkLst>
-            <pc:docMk/>
-            <pc:sldMk cId="3732443723" sldId="682"/>
-            <ac:spMk id="6" creationId="{1F20852B-EB26-09DA-BBAA-22B49709516A}"/>
-          </ac:spMkLst>
-        </pc:spChg>
-        <pc:picChg chg="add del mod">
-          <ac:chgData name="diagramador@aprovasim.com" userId="08c27f4fd777aeb1" providerId="LiveId" clId="{6DA82D89-F719-4B18-ABAA-0D43E56AF532}" dt="2026-02-11T19:35:57.759" v="4041" actId="478"/>
-          <ac:picMkLst>
-            <pc:docMk/>
-            <pc:sldMk cId="3732443723" sldId="682"/>
-            <ac:picMk id="3" creationId="{F4F7C71A-43BB-7BD1-B425-4BBB5B8E2382}"/>
-          </ac:picMkLst>
-        </pc:picChg>
-        <pc:picChg chg="add mod">
-          <ac:chgData name="diagramador@aprovasim.com" userId="08c27f4fd777aeb1" providerId="LiveId" clId="{6DA82D89-F719-4B18-ABAA-0D43E56AF532}" dt="2026-02-11T20:07:37.628" v="4292" actId="732"/>
-          <ac:picMkLst>
-            <pc:docMk/>
-            <pc:sldMk cId="3732443723" sldId="682"/>
-            <ac:picMk id="6146" creationId="{F61932A3-3BB0-73A5-529B-F39553951CF8}"/>
-          </ac:picMkLst>
-        </pc:picChg>
-      </pc:sldChg>
-      <pc:sldChg chg="addSp delSp modSp add mod">
-        <pc:chgData name="diagramador@aprovasim.com" userId="08c27f4fd777aeb1" providerId="LiveId" clId="{6DA82D89-F719-4B18-ABAA-0D43E56AF532}" dt="2026-02-12T11:50:20.287" v="4441" actId="732"/>
-        <pc:sldMkLst>
-          <pc:docMk/>
-          <pc:sldMk cId="3042870659" sldId="683"/>
-        </pc:sldMkLst>
-        <pc:spChg chg="add del">
-          <ac:chgData name="diagramador@aprovasim.com" userId="08c27f4fd777aeb1" providerId="LiveId" clId="{6DA82D89-F719-4B18-ABAA-0D43E56AF532}" dt="2026-02-12T11:49:19.588" v="4428" actId="478"/>
-          <ac:spMkLst>
-            <pc:docMk/>
-            <pc:sldMk cId="3042870659" sldId="683"/>
-            <ac:spMk id="3" creationId="{A6C1220F-A6ED-6FF2-C688-76A6C4C730DA}"/>
-          </ac:spMkLst>
-        </pc:spChg>
-        <pc:spChg chg="mod">
-          <ac:chgData name="diagramador@aprovasim.com" userId="08c27f4fd777aeb1" providerId="LiveId" clId="{6DA82D89-F719-4B18-ABAA-0D43E56AF532}" dt="2026-02-11T19:38:34.781" v="4062" actId="14100"/>
-          <ac:spMkLst>
-            <pc:docMk/>
-            <pc:sldMk cId="3042870659" sldId="683"/>
-            <ac:spMk id="5" creationId="{91119945-7F47-BA68-672C-F6E13EB9F307}"/>
-          </ac:spMkLst>
-        </pc:spChg>
-        <pc:spChg chg="mod">
-          <ac:chgData name="diagramador@aprovasim.com" userId="08c27f4fd777aeb1" providerId="LiveId" clId="{6DA82D89-F719-4B18-ABAA-0D43E56AF532}" dt="2026-02-11T19:38:46.514" v="4065" actId="14100"/>
-          <ac:spMkLst>
-            <pc:docMk/>
-            <pc:sldMk cId="3042870659" sldId="683"/>
-            <ac:spMk id="6" creationId="{58EBFA9C-35AC-A952-59DA-25C85E25B247}"/>
-          </ac:spMkLst>
-        </pc:spChg>
-        <pc:graphicFrameChg chg="add del mod">
-          <ac:chgData name="diagramador@aprovasim.com" userId="08c27f4fd777aeb1" providerId="LiveId" clId="{6DA82D89-F719-4B18-ABAA-0D43E56AF532}" dt="2026-02-12T11:49:29.122" v="4431"/>
-          <ac:graphicFrameMkLst>
-            <pc:docMk/>
-            <pc:sldMk cId="3042870659" sldId="683"/>
-            <ac:graphicFrameMk id="4" creationId="{4DF4E34B-CCE1-2AC7-BC9F-E9B573E113D3}"/>
-          </ac:graphicFrameMkLst>
-        </pc:graphicFrameChg>
-        <pc:picChg chg="add del mod">
-          <ac:chgData name="diagramador@aprovasim.com" userId="08c27f4fd777aeb1" providerId="LiveId" clId="{6DA82D89-F719-4B18-ABAA-0D43E56AF532}" dt="2026-02-11T19:38:47.936" v="4066" actId="478"/>
-          <ac:picMkLst>
-            <pc:docMk/>
-            <pc:sldMk cId="3042870659" sldId="683"/>
-            <ac:picMk id="3" creationId="{5CC0171A-DE51-5C11-8041-21AA07B13A71}"/>
-          </ac:picMkLst>
-        </pc:picChg>
-        <pc:picChg chg="add mod ord modCrop">
-          <ac:chgData name="diagramador@aprovasim.com" userId="08c27f4fd777aeb1" providerId="LiveId" clId="{6DA82D89-F719-4B18-ABAA-0D43E56AF532}" dt="2026-02-12T11:50:20.287" v="4441" actId="732"/>
-          <ac:picMkLst>
-            <pc:docMk/>
-            <pc:sldMk cId="3042870659" sldId="683"/>
-            <ac:picMk id="7" creationId="{4CAEE751-91D2-C088-0B72-93C06270D7EC}"/>
-          </ac:picMkLst>
-        </pc:picChg>
-      </pc:sldChg>
-      <pc:sldChg chg="addSp delSp modSp add mod">
-        <pc:chgData name="diagramador@aprovasim.com" userId="08c27f4fd777aeb1" providerId="LiveId" clId="{6DA82D89-F719-4B18-ABAA-0D43E56AF532}" dt="2026-02-11T20:21:01.253" v="4302" actId="732"/>
-        <pc:sldMkLst>
-          <pc:docMk/>
-          <pc:sldMk cId="3513172090" sldId="684"/>
-        </pc:sldMkLst>
-        <pc:spChg chg="mod">
-          <ac:chgData name="diagramador@aprovasim.com" userId="08c27f4fd777aeb1" providerId="LiveId" clId="{6DA82D89-F719-4B18-ABAA-0D43E56AF532}" dt="2026-02-11T19:40:28.939" v="4085" actId="14100"/>
-          <ac:spMkLst>
-            <pc:docMk/>
-            <pc:sldMk cId="3513172090" sldId="684"/>
-            <ac:spMk id="5" creationId="{2C4E2F35-E6B2-2165-F3F0-34EE17C57BAE}"/>
-          </ac:spMkLst>
-        </pc:spChg>
-        <pc:spChg chg="mod">
-          <ac:chgData name="diagramador@aprovasim.com" userId="08c27f4fd777aeb1" providerId="LiveId" clId="{6DA82D89-F719-4B18-ABAA-0D43E56AF532}" dt="2026-02-11T19:40:16.953" v="4083"/>
-          <ac:spMkLst>
-            <pc:docMk/>
-            <pc:sldMk cId="3513172090" sldId="684"/>
-            <ac:spMk id="6" creationId="{2140A440-EF0D-175A-13B5-02457A630A5F}"/>
-          </ac:spMkLst>
-        </pc:spChg>
-        <pc:picChg chg="add del mod">
-          <ac:chgData name="diagramador@aprovasim.com" userId="08c27f4fd777aeb1" providerId="LiveId" clId="{6DA82D89-F719-4B18-ABAA-0D43E56AF532}" dt="2026-02-11T19:40:19.077" v="4084" actId="478"/>
-          <ac:picMkLst>
-            <pc:docMk/>
-            <pc:sldMk cId="3513172090" sldId="684"/>
-            <ac:picMk id="3" creationId="{55C347F8-765F-7858-32F1-78CF0A060F87}"/>
-          </ac:picMkLst>
-        </pc:picChg>
-        <pc:picChg chg="add mod">
-          <ac:chgData name="diagramador@aprovasim.com" userId="08c27f4fd777aeb1" providerId="LiveId" clId="{6DA82D89-F719-4B18-ABAA-0D43E56AF532}" dt="2026-02-11T20:21:01.253" v="4302" actId="732"/>
-          <ac:picMkLst>
-            <pc:docMk/>
-            <pc:sldMk cId="3513172090" sldId="684"/>
-            <ac:picMk id="8194" creationId="{AC56FEBF-CC61-0C70-8B31-CADB8BC3D229}"/>
-          </ac:picMkLst>
-        </pc:picChg>
-      </pc:sldChg>
-      <pc:sldChg chg="addSp delSp modSp add mod">
-        <pc:chgData name="diagramador@aprovasim.com" userId="08c27f4fd777aeb1" providerId="LiveId" clId="{6DA82D89-F719-4B18-ABAA-0D43E56AF532}" dt="2026-02-11T20:26:04.471" v="4321" actId="732"/>
-        <pc:sldMkLst>
-          <pc:docMk/>
-          <pc:sldMk cId="1472739186" sldId="685"/>
-        </pc:sldMkLst>
-        <pc:spChg chg="mod">
-          <ac:chgData name="diagramador@aprovasim.com" userId="08c27f4fd777aeb1" providerId="LiveId" clId="{6DA82D89-F719-4B18-ABAA-0D43E56AF532}" dt="2026-02-11T19:41:23.686" v="4096" actId="255"/>
-          <ac:spMkLst>
-            <pc:docMk/>
-            <pc:sldMk cId="1472739186" sldId="685"/>
-            <ac:spMk id="5" creationId="{E8F08714-F6C2-34F2-BC49-9EFCFCBAA70C}"/>
-          </ac:spMkLst>
-        </pc:spChg>
-        <pc:spChg chg="mod">
-          <ac:chgData name="diagramador@aprovasim.com" userId="08c27f4fd777aeb1" providerId="LiveId" clId="{6DA82D89-F719-4B18-ABAA-0D43E56AF532}" dt="2026-02-11T19:41:48.557" v="4101" actId="14100"/>
-          <ac:spMkLst>
-            <pc:docMk/>
-            <pc:sldMk cId="1472739186" sldId="685"/>
-            <ac:spMk id="6" creationId="{29372B27-FD65-643C-4BA4-15FBAE0865DE}"/>
-          </ac:spMkLst>
-        </pc:spChg>
-        <pc:picChg chg="add del mod">
-          <ac:chgData name="diagramador@aprovasim.com" userId="08c27f4fd777aeb1" providerId="LiveId" clId="{6DA82D89-F719-4B18-ABAA-0D43E56AF532}" dt="2026-02-11T19:41:59.736" v="4102" actId="478"/>
-          <ac:picMkLst>
-            <pc:docMk/>
-            <pc:sldMk cId="1472739186" sldId="685"/>
-            <ac:picMk id="3" creationId="{729D14DA-B739-3BD1-C100-4AB34A2BAA03}"/>
-          </ac:picMkLst>
-        </pc:picChg>
-        <pc:picChg chg="add del mod">
-          <ac:chgData name="diagramador@aprovasim.com" userId="08c27f4fd777aeb1" providerId="LiveId" clId="{6DA82D89-F719-4B18-ABAA-0D43E56AF532}" dt="2026-02-11T20:25:37.346" v="4317" actId="478"/>
-          <ac:picMkLst>
-            <pc:docMk/>
-            <pc:sldMk cId="1472739186" sldId="685"/>
-            <ac:picMk id="10242" creationId="{0107540C-5F3D-03E4-1C5D-1F6B926D949F}"/>
-          </ac:picMkLst>
-        </pc:picChg>
-        <pc:picChg chg="add mod">
-          <ac:chgData name="diagramador@aprovasim.com" userId="08c27f4fd777aeb1" providerId="LiveId" clId="{6DA82D89-F719-4B18-ABAA-0D43E56AF532}" dt="2026-02-11T20:26:04.471" v="4321" actId="732"/>
-          <ac:picMkLst>
-            <pc:docMk/>
-            <pc:sldMk cId="1472739186" sldId="685"/>
-            <ac:picMk id="10244" creationId="{D04DAA4C-F47E-4C91-9CD3-C71343EF2BAE}"/>
-          </ac:picMkLst>
-        </pc:picChg>
-      </pc:sldChg>
-      <pc:sldChg chg="addSp delSp modSp add mod">
-        <pc:chgData name="diagramador@aprovasim.com" userId="08c27f4fd777aeb1" providerId="LiveId" clId="{6DA82D89-F719-4B18-ABAA-0D43E56AF532}" dt="2026-02-11T20:33:11.350" v="4335" actId="732"/>
-        <pc:sldMkLst>
-          <pc:docMk/>
-          <pc:sldMk cId="2400252335" sldId="686"/>
-        </pc:sldMkLst>
-        <pc:spChg chg="add mod">
-          <ac:chgData name="diagramador@aprovasim.com" userId="08c27f4fd777aeb1" providerId="LiveId" clId="{6DA82D89-F719-4B18-ABAA-0D43E56AF532}" dt="2026-02-11T19:55:00.270" v="4204" actId="20577"/>
-          <ac:spMkLst>
-            <pc:docMk/>
-            <pc:sldMk cId="2400252335" sldId="686"/>
-            <ac:spMk id="4" creationId="{33645607-7CA5-A40E-FA31-B66221B33710}"/>
-          </ac:spMkLst>
-        </pc:spChg>
-        <pc:spChg chg="mod">
-          <ac:chgData name="diagramador@aprovasim.com" userId="08c27f4fd777aeb1" providerId="LiveId" clId="{6DA82D89-F719-4B18-ABAA-0D43E56AF532}" dt="2026-02-11T19:55:04.479" v="4205" actId="1076"/>
-          <ac:spMkLst>
-            <pc:docMk/>
-            <pc:sldMk cId="2400252335" sldId="686"/>
-            <ac:spMk id="5" creationId="{FF6D88B3-C175-1738-94B1-309DD6B35704}"/>
-          </ac:spMkLst>
-        </pc:spChg>
-        <pc:spChg chg="mod">
-          <ac:chgData name="diagramador@aprovasim.com" userId="08c27f4fd777aeb1" providerId="LiveId" clId="{6DA82D89-F719-4B18-ABAA-0D43E56AF532}" dt="2026-02-11T19:54:52.430" v="4194" actId="1076"/>
-          <ac:spMkLst>
-            <pc:docMk/>
-            <pc:sldMk cId="2400252335" sldId="686"/>
-            <ac:spMk id="6" creationId="{C913825A-E8F7-CE60-40A1-B10A930BE439}"/>
-          </ac:spMkLst>
-        </pc:spChg>
-        <pc:picChg chg="add del mod">
-          <ac:chgData name="diagramador@aprovasim.com" userId="08c27f4fd777aeb1" providerId="LiveId" clId="{6DA82D89-F719-4B18-ABAA-0D43E56AF532}" dt="2026-02-11T19:42:59.873" v="4115" actId="478"/>
-          <ac:picMkLst>
-            <pc:docMk/>
-            <pc:sldMk cId="2400252335" sldId="686"/>
-            <ac:picMk id="3" creationId="{09DF8294-84DA-663E-5624-A9D32BF934C2}"/>
-          </ac:picMkLst>
-        </pc:picChg>
-        <pc:picChg chg="add del mod">
-          <ac:chgData name="diagramador@aprovasim.com" userId="08c27f4fd777aeb1" providerId="LiveId" clId="{6DA82D89-F719-4B18-ABAA-0D43E56AF532}" dt="2026-02-11T20:31:13.601" v="4329" actId="478"/>
-          <ac:picMkLst>
-            <pc:docMk/>
-            <pc:sldMk cId="2400252335" sldId="686"/>
-            <ac:picMk id="12290" creationId="{BE8859E1-FC04-7325-76AF-8420B90AA504}"/>
-          </ac:picMkLst>
-        </pc:picChg>
-        <pc:picChg chg="add mod">
-          <ac:chgData name="diagramador@aprovasim.com" userId="08c27f4fd777aeb1" providerId="LiveId" clId="{6DA82D89-F719-4B18-ABAA-0D43E56AF532}" dt="2026-02-11T20:33:11.350" v="4335" actId="732"/>
-          <ac:picMkLst>
-            <pc:docMk/>
-            <pc:sldMk cId="2400252335" sldId="686"/>
-            <ac:picMk id="12292" creationId="{18978955-76B3-3587-C74E-F9E43905867A}"/>
-          </ac:picMkLst>
-        </pc:picChg>
-      </pc:sldChg>
-      <pc:sldChg chg="addSp delSp modSp add mod">
-        <pc:chgData name="diagramador@aprovasim.com" userId="08c27f4fd777aeb1" providerId="LiveId" clId="{6DA82D89-F719-4B18-ABAA-0D43E56AF532}" dt="2026-02-11T20:40:49.211" v="4354" actId="478"/>
-        <pc:sldMkLst>
-          <pc:docMk/>
-          <pc:sldMk cId="752070531" sldId="687"/>
-        </pc:sldMkLst>
-        <pc:spChg chg="add mod">
-          <ac:chgData name="diagramador@aprovasim.com" userId="08c27f4fd777aeb1" providerId="LiveId" clId="{6DA82D89-F719-4B18-ABAA-0D43E56AF532}" dt="2026-02-11T19:55:55.667" v="4212" actId="20577"/>
-          <ac:spMkLst>
-            <pc:docMk/>
-            <pc:sldMk cId="752070531" sldId="687"/>
-            <ac:spMk id="4" creationId="{F983D73B-EA8F-03EA-E015-F88B9770ED88}"/>
-          </ac:spMkLst>
-        </pc:spChg>
-        <pc:spChg chg="mod">
-          <ac:chgData name="diagramador@aprovasim.com" userId="08c27f4fd777aeb1" providerId="LiveId" clId="{6DA82D89-F719-4B18-ABAA-0D43E56AF532}" dt="2026-02-11T19:56:01.590" v="4213" actId="1076"/>
-          <ac:spMkLst>
-            <pc:docMk/>
-            <pc:sldMk cId="752070531" sldId="687"/>
-            <ac:spMk id="5" creationId="{52FA2653-CFBF-BDAE-1B07-8899A63290D7}"/>
-          </ac:spMkLst>
-        </pc:spChg>
-        <pc:spChg chg="mod">
-          <ac:chgData name="diagramador@aprovasim.com" userId="08c27f4fd777aeb1" providerId="LiveId" clId="{6DA82D89-F719-4B18-ABAA-0D43E56AF532}" dt="2026-02-11T19:55:48.527" v="4206" actId="1076"/>
-          <ac:spMkLst>
-            <pc:docMk/>
-            <pc:sldMk cId="752070531" sldId="687"/>
-            <ac:spMk id="6" creationId="{C9A27D02-D393-18BA-029F-770D2BD08AFF}"/>
-          </ac:spMkLst>
-        </pc:spChg>
-        <pc:picChg chg="add del mod">
-          <ac:chgData name="diagramador@aprovasim.com" userId="08c27f4fd777aeb1" providerId="LiveId" clId="{6DA82D89-F719-4B18-ABAA-0D43E56AF532}" dt="2026-02-11T19:44:11.595" v="4128" actId="478"/>
-          <ac:picMkLst>
-            <pc:docMk/>
-            <pc:sldMk cId="752070531" sldId="687"/>
-            <ac:picMk id="3" creationId="{A0CAD27E-DFE3-28CD-3696-A34462A6A4AD}"/>
-          </ac:picMkLst>
-        </pc:picChg>
-        <pc:picChg chg="add del mod">
-          <ac:chgData name="diagramador@aprovasim.com" userId="08c27f4fd777aeb1" providerId="LiveId" clId="{6DA82D89-F719-4B18-ABAA-0D43E56AF532}" dt="2026-02-11T20:40:49.211" v="4354" actId="478"/>
-          <ac:picMkLst>
-            <pc:docMk/>
-            <pc:sldMk cId="752070531" sldId="687"/>
-            <ac:picMk id="14338" creationId="{979FB6F1-40D5-BF6B-B5FE-89542E53C549}"/>
-          </ac:picMkLst>
-        </pc:picChg>
-        <pc:picChg chg="add del mod">
-          <ac:chgData name="diagramador@aprovasim.com" userId="08c27f4fd777aeb1" providerId="LiveId" clId="{6DA82D89-F719-4B18-ABAA-0D43E56AF532}" dt="2026-02-11T20:40:48.321" v="4353" actId="1076"/>
-          <ac:picMkLst>
-            <pc:docMk/>
-            <pc:sldMk cId="752070531" sldId="687"/>
-            <ac:picMk id="14340" creationId="{0939D833-212A-41B9-3824-2473C6DD63C4}"/>
-          </ac:picMkLst>
-        </pc:picChg>
-        <pc:picChg chg="add">
-          <ac:chgData name="diagramador@aprovasim.com" userId="08c27f4fd777aeb1" providerId="LiveId" clId="{6DA82D89-F719-4B18-ABAA-0D43E56AF532}" dt="2026-02-11T20:40:45.784" v="4350"/>
-          <ac:picMkLst>
-            <pc:docMk/>
-            <pc:sldMk cId="752070531" sldId="687"/>
-            <ac:picMk id="14342" creationId="{F740F81E-1C1B-AB50-09B4-1EF17440FBC3}"/>
-          </ac:picMkLst>
-        </pc:picChg>
-      </pc:sldChg>
-      <pc:sldChg chg="addSp delSp modSp add mod">
-        <pc:chgData name="diagramador@aprovasim.com" userId="08c27f4fd777aeb1" providerId="LiveId" clId="{6DA82D89-F719-4B18-ABAA-0D43E56AF532}" dt="2026-02-11T20:47:03.456" v="4380" actId="1076"/>
-        <pc:sldMkLst>
-          <pc:docMk/>
-          <pc:sldMk cId="696374618" sldId="688"/>
-        </pc:sldMkLst>
-        <pc:spChg chg="mod">
-          <ac:chgData name="diagramador@aprovasim.com" userId="08c27f4fd777aeb1" providerId="LiveId" clId="{6DA82D89-F719-4B18-ABAA-0D43E56AF532}" dt="2026-02-11T19:45:03.949" v="4140" actId="255"/>
-          <ac:spMkLst>
-            <pc:docMk/>
-            <pc:sldMk cId="696374618" sldId="688"/>
-            <ac:spMk id="5" creationId="{3F7C848A-3C3B-8636-E45A-E65E9235C81D}"/>
-          </ac:spMkLst>
-        </pc:spChg>
-        <pc:spChg chg="mod">
-          <ac:chgData name="diagramador@aprovasim.com" userId="08c27f4fd777aeb1" providerId="LiveId" clId="{6DA82D89-F719-4B18-ABAA-0D43E56AF532}" dt="2026-02-11T19:45:11.263" v="4141"/>
-          <ac:spMkLst>
-            <pc:docMk/>
-            <pc:sldMk cId="696374618" sldId="688"/>
-            <ac:spMk id="6" creationId="{0FEF22CB-BE2D-9D8C-CBA5-966C323A7D79}"/>
-          </ac:spMkLst>
-        </pc:spChg>
-        <pc:picChg chg="add del mod">
-          <ac:chgData name="diagramador@aprovasim.com" userId="08c27f4fd777aeb1" providerId="LiveId" clId="{6DA82D89-F719-4B18-ABAA-0D43E56AF532}" dt="2026-02-11T19:45:16.617" v="4142" actId="478"/>
-          <ac:picMkLst>
-            <pc:docMk/>
-            <pc:sldMk cId="696374618" sldId="688"/>
-            <ac:picMk id="3" creationId="{6EF71735-5D48-44A8-359F-2DC7E2C1A941}"/>
-          </ac:picMkLst>
-        </pc:picChg>
-        <pc:picChg chg="add mod">
-          <ac:chgData name="diagramador@aprovasim.com" userId="08c27f4fd777aeb1" providerId="LiveId" clId="{6DA82D89-F719-4B18-ABAA-0D43E56AF532}" dt="2026-02-11T20:47:03.456" v="4380" actId="1076"/>
-          <ac:picMkLst>
-            <pc:docMk/>
-            <pc:sldMk cId="696374618" sldId="688"/>
-            <ac:picMk id="16386" creationId="{FBDD9477-1C77-C868-8CD2-6C6727E4BCB8}"/>
-          </ac:picMkLst>
-        </pc:picChg>
-      </pc:sldChg>
-      <pc:sldChg chg="addSp modSp add del mod">
-        <pc:chgData name="diagramador@aprovasim.com" userId="08c27f4fd777aeb1" providerId="LiveId" clId="{6DA82D89-F719-4B18-ABAA-0D43E56AF532}" dt="2026-02-11T19:58:15.436" v="4241" actId="47"/>
-        <pc:sldMkLst>
-          <pc:docMk/>
-          <pc:sldMk cId="4084904341" sldId="689"/>
-        </pc:sldMkLst>
-      </pc:sldChg>
-      <pc:sldChg chg="addSp modSp add del mod">
-        <pc:chgData name="diagramador@aprovasim.com" userId="08c27f4fd777aeb1" providerId="LiveId" clId="{6DA82D89-F719-4B18-ABAA-0D43E56AF532}" dt="2026-02-11T19:58:15.436" v="4241" actId="47"/>
-        <pc:sldMkLst>
-          <pc:docMk/>
-          <pc:sldMk cId="1078727808" sldId="690"/>
-        </pc:sldMkLst>
-      </pc:sldChg>
-      <pc:sldChg chg="addSp delSp modSp add del mod">
-        <pc:chgData name="diagramador@aprovasim.com" userId="08c27f4fd777aeb1" providerId="LiveId" clId="{6DA82D89-F719-4B18-ABAA-0D43E56AF532}" dt="2026-02-11T19:58:15.436" v="4241" actId="47"/>
-        <pc:sldMkLst>
-          <pc:docMk/>
-          <pc:sldMk cId="3095765858" sldId="691"/>
-        </pc:sldMkLst>
-      </pc:sldChg>
-      <pc:sldChg chg="addSp delSp modSp add del mod">
-        <pc:chgData name="diagramador@aprovasim.com" userId="08c27f4fd777aeb1" providerId="LiveId" clId="{6DA82D89-F719-4B18-ABAA-0D43E56AF532}" dt="2026-02-11T19:58:15.436" v="4241" actId="47"/>
-        <pc:sldMkLst>
-          <pc:docMk/>
-          <pc:sldMk cId="1014298765" sldId="692"/>
-        </pc:sldMkLst>
-      </pc:sldChg>
-      <pc:sldChg chg="addSp modSp add del mod">
-        <pc:chgData name="diagramador@aprovasim.com" userId="08c27f4fd777aeb1" providerId="LiveId" clId="{6DA82D89-F719-4B18-ABAA-0D43E56AF532}" dt="2026-02-11T19:58:15.436" v="4241" actId="47"/>
-        <pc:sldMkLst>
-          <pc:docMk/>
-          <pc:sldMk cId="3547039015" sldId="693"/>
-        </pc:sldMkLst>
-      </pc:sldChg>
-      <pc:sldChg chg="addSp delSp modSp add del mod">
-        <pc:chgData name="diagramador@aprovasim.com" userId="08c27f4fd777aeb1" providerId="LiveId" clId="{6DA82D89-F719-4B18-ABAA-0D43E56AF532}" dt="2026-02-11T19:58:15.436" v="4241" actId="47"/>
-        <pc:sldMkLst>
-          <pc:docMk/>
-          <pc:sldMk cId="59237358" sldId="694"/>
-        </pc:sldMkLst>
-      </pc:sldChg>
-      <pc:sldChg chg="addSp delSp modSp add del mod">
-        <pc:chgData name="diagramador@aprovasim.com" userId="08c27f4fd777aeb1" providerId="LiveId" clId="{6DA82D89-F719-4B18-ABAA-0D43E56AF532}" dt="2026-02-11T19:58:15.436" v="4241" actId="47"/>
-        <pc:sldMkLst>
-          <pc:docMk/>
-          <pc:sldMk cId="3058694010" sldId="695"/>
-        </pc:sldMkLst>
-      </pc:sldChg>
-      <pc:sldChg chg="addSp modSp add del mod">
-        <pc:chgData name="diagramador@aprovasim.com" userId="08c27f4fd777aeb1" providerId="LiveId" clId="{6DA82D89-F719-4B18-ABAA-0D43E56AF532}" dt="2026-02-11T19:58:15.436" v="4241" actId="47"/>
-        <pc:sldMkLst>
-          <pc:docMk/>
-          <pc:sldMk cId="3611018030" sldId="696"/>
-        </pc:sldMkLst>
-      </pc:sldChg>
-      <pc:sldChg chg="addSp modSp add del mod">
-        <pc:chgData name="diagramador@aprovasim.com" userId="08c27f4fd777aeb1" providerId="LiveId" clId="{6DA82D89-F719-4B18-ABAA-0D43E56AF532}" dt="2026-02-11T19:58:15.436" v="4241" actId="47"/>
-        <pc:sldMkLst>
-          <pc:docMk/>
-          <pc:sldMk cId="2998023171" sldId="697"/>
-        </pc:sldMkLst>
-      </pc:sldChg>
-      <pc:sldChg chg="addSp modSp add del mod">
-        <pc:chgData name="diagramador@aprovasim.com" userId="08c27f4fd777aeb1" providerId="LiveId" clId="{6DA82D89-F719-4B18-ABAA-0D43E56AF532}" dt="2026-02-11T19:58:15.436" v="4241" actId="47"/>
-        <pc:sldMkLst>
-          <pc:docMk/>
-          <pc:sldMk cId="4177879266" sldId="698"/>
-        </pc:sldMkLst>
-      </pc:sldChg>
-      <pc:sldChg chg="addSp modSp add del mod">
-        <pc:chgData name="diagramador@aprovasim.com" userId="08c27f4fd777aeb1" providerId="LiveId" clId="{6DA82D89-F719-4B18-ABAA-0D43E56AF532}" dt="2026-02-11T19:58:15.436" v="4241" actId="47"/>
-        <pc:sldMkLst>
-          <pc:docMk/>
-          <pc:sldMk cId="3494387411" sldId="699"/>
-        </pc:sldMkLst>
-      </pc:sldChg>
-      <pc:sldChg chg="addSp delSp modSp add del mod ord">
-        <pc:chgData name="diagramador@aprovasim.com" userId="08c27f4fd777aeb1" providerId="LiveId" clId="{6DA82D89-F719-4B18-ABAA-0D43E56AF532}" dt="2026-02-11T19:58:15.436" v="4241" actId="47"/>
-        <pc:sldMkLst>
-          <pc:docMk/>
-          <pc:sldMk cId="853046686" sldId="700"/>
-        </pc:sldMkLst>
-      </pc:sldChg>
-      <pc:sldChg chg="addSp modSp add del mod">
-        <pc:chgData name="diagramador@aprovasim.com" userId="08c27f4fd777aeb1" providerId="LiveId" clId="{6DA82D89-F719-4B18-ABAA-0D43E56AF532}" dt="2026-02-11T19:58:15.436" v="4241" actId="47"/>
-        <pc:sldMkLst>
-          <pc:docMk/>
-          <pc:sldMk cId="3383532346" sldId="701"/>
-        </pc:sldMkLst>
-      </pc:sldChg>
-      <pc:sldChg chg="addSp delSp modSp add mod">
-        <pc:chgData name="diagramador@aprovasim.com" userId="08c27f4fd777aeb1" providerId="LiveId" clId="{6DA82D89-F719-4B18-ABAA-0D43E56AF532}" dt="2026-02-11T20:49:03.581" v="4393" actId="732"/>
-        <pc:sldMkLst>
-          <pc:docMk/>
-          <pc:sldMk cId="3468674505" sldId="702"/>
-        </pc:sldMkLst>
-        <pc:spChg chg="add del">
-          <ac:chgData name="diagramador@aprovasim.com" userId="08c27f4fd777aeb1" providerId="LiveId" clId="{6DA82D89-F719-4B18-ABAA-0D43E56AF532}" dt="2026-02-11T20:48:27.056" v="4382" actId="478"/>
-          <ac:spMkLst>
-            <pc:docMk/>
-            <pc:sldMk cId="3468674505" sldId="702"/>
-            <ac:spMk id="3" creationId="{3D106956-902D-6106-D09A-D64BF9DC5F97}"/>
-          </ac:spMkLst>
-        </pc:spChg>
-        <pc:spChg chg="add del">
-          <ac:chgData name="diagramador@aprovasim.com" userId="08c27f4fd777aeb1" providerId="LiveId" clId="{6DA82D89-F719-4B18-ABAA-0D43E56AF532}" dt="2026-02-11T20:48:35.266" v="4384" actId="478"/>
-          <ac:spMkLst>
-            <pc:docMk/>
-            <pc:sldMk cId="3468674505" sldId="702"/>
-            <ac:spMk id="4" creationId="{E9D583F8-065F-82EE-1459-DADFA17C9541}"/>
-          </ac:spMkLst>
-        </pc:spChg>
-        <pc:spChg chg="mod">
-          <ac:chgData name="diagramador@aprovasim.com" userId="08c27f4fd777aeb1" providerId="LiveId" clId="{6DA82D89-F719-4B18-ABAA-0D43E56AF532}" dt="2026-02-11T19:49:36.710" v="4145"/>
-          <ac:spMkLst>
-            <pc:docMk/>
-            <pc:sldMk cId="3468674505" sldId="702"/>
-            <ac:spMk id="5" creationId="{8C626DE7-F837-EB7C-89C3-2485CB23EAD6}"/>
-          </ac:spMkLst>
-        </pc:spChg>
-        <pc:spChg chg="mod">
-          <ac:chgData name="diagramador@aprovasim.com" userId="08c27f4fd777aeb1" providerId="LiveId" clId="{6DA82D89-F719-4B18-ABAA-0D43E56AF532}" dt="2026-02-11T19:49:48.944" v="4148" actId="20577"/>
-          <ac:spMkLst>
-            <pc:docMk/>
-            <pc:sldMk cId="3468674505" sldId="702"/>
-            <ac:spMk id="6" creationId="{4AAD234B-070F-7E17-EBB5-6CB8FF746B41}"/>
-          </ac:spMkLst>
-        </pc:spChg>
-        <pc:graphicFrameChg chg="add del mod">
-          <ac:chgData name="diagramador@aprovasim.com" userId="08c27f4fd777aeb1" providerId="LiveId" clId="{6DA82D89-F719-4B18-ABAA-0D43E56AF532}" dt="2026-02-11T20:48:49.476" v="4387"/>
-          <ac:graphicFrameMkLst>
-            <pc:docMk/>
-            <pc:sldMk cId="3468674505" sldId="702"/>
-            <ac:graphicFrameMk id="7" creationId="{9DFB2249-C9B4-4D72-11C5-0528272CCAF3}"/>
-          </ac:graphicFrameMkLst>
-        </pc:graphicFrameChg>
-        <pc:picChg chg="add mod ord modCrop">
-          <ac:chgData name="diagramador@aprovasim.com" userId="08c27f4fd777aeb1" providerId="LiveId" clId="{6DA82D89-F719-4B18-ABAA-0D43E56AF532}" dt="2026-02-11T20:49:03.581" v="4393" actId="732"/>
-          <ac:picMkLst>
-            <pc:docMk/>
-            <pc:sldMk cId="3468674505" sldId="702"/>
-            <ac:picMk id="8" creationId="{F0E0EA26-89E1-F4DB-D0DB-CC8F586085D7}"/>
-          </ac:picMkLst>
-        </pc:picChg>
-      </pc:sldChg>
-      <pc:sldChg chg="addSp delSp modSp add mod">
-        <pc:chgData name="diagramador@aprovasim.com" userId="08c27f4fd777aeb1" providerId="LiveId" clId="{6DA82D89-F719-4B18-ABAA-0D43E56AF532}" dt="2026-02-12T16:13:21.671" v="4525" actId="732"/>
-        <pc:sldMkLst>
-          <pc:docMk/>
-          <pc:sldMk cId="996686889" sldId="703"/>
-        </pc:sldMkLst>
-        <pc:spChg chg="mod">
-          <ac:chgData name="diagramador@aprovasim.com" userId="08c27f4fd777aeb1" providerId="LiveId" clId="{6DA82D89-F719-4B18-ABAA-0D43E56AF532}" dt="2026-02-11T19:50:23.560" v="4151"/>
-          <ac:spMkLst>
-            <pc:docMk/>
-            <pc:sldMk cId="996686889" sldId="703"/>
-            <ac:spMk id="5" creationId="{E1B525D5-CFCA-8007-C25B-A0B6DAED766F}"/>
-          </ac:spMkLst>
-        </pc:spChg>
-        <pc:spChg chg="mod">
-          <ac:chgData name="diagramador@aprovasim.com" userId="08c27f4fd777aeb1" providerId="LiveId" clId="{6DA82D89-F719-4B18-ABAA-0D43E56AF532}" dt="2026-02-11T19:50:39.783" v="4153" actId="14100"/>
-          <ac:spMkLst>
-            <pc:docMk/>
-            <pc:sldMk cId="996686889" sldId="703"/>
-            <ac:spMk id="6" creationId="{50B24AC9-0C87-E54B-4B50-E677D1821125}"/>
-          </ac:spMkLst>
-        </pc:spChg>
-        <pc:picChg chg="add del mod">
-          <ac:chgData name="diagramador@aprovasim.com" userId="08c27f4fd777aeb1" providerId="LiveId" clId="{6DA82D89-F719-4B18-ABAA-0D43E56AF532}" dt="2026-02-12T16:13:11.304" v="4520" actId="478"/>
-          <ac:picMkLst>
-            <pc:docMk/>
-            <pc:sldMk cId="996686889" sldId="703"/>
-            <ac:picMk id="1026" creationId="{57505222-1B32-8074-D36E-B2D35F4A4B2D}"/>
-          </ac:picMkLst>
-        </pc:picChg>
-        <pc:picChg chg="add mod">
-          <ac:chgData name="diagramador@aprovasim.com" userId="08c27f4fd777aeb1" providerId="LiveId" clId="{6DA82D89-F719-4B18-ABAA-0D43E56AF532}" dt="2026-02-12T16:13:21.671" v="4525" actId="732"/>
-          <ac:picMkLst>
-            <pc:docMk/>
-            <pc:sldMk cId="996686889" sldId="703"/>
-            <ac:picMk id="1028" creationId="{781359BE-1654-A0AD-7439-388E345DEBDC}"/>
-          </ac:picMkLst>
-        </pc:picChg>
-        <pc:picChg chg="add del mod">
-          <ac:chgData name="diagramador@aprovasim.com" userId="08c27f4fd777aeb1" providerId="LiveId" clId="{6DA82D89-F719-4B18-ABAA-0D43E56AF532}" dt="2026-02-12T16:08:17.066" v="4514" actId="478"/>
-          <ac:picMkLst>
-            <pc:docMk/>
-            <pc:sldMk cId="996686889" sldId="703"/>
-            <ac:picMk id="18434" creationId="{275F3891-BFC5-8CB0-7CC1-28F785FBEAB6}"/>
-          </ac:picMkLst>
-        </pc:picChg>
-      </pc:sldChg>
-      <pc:sldChg chg="addSp modSp add mod">
-        <pc:chgData name="diagramador@aprovasim.com" userId="08c27f4fd777aeb1" providerId="LiveId" clId="{6DA82D89-F719-4B18-ABAA-0D43E56AF532}" dt="2026-02-12T13:48:30.936" v="4513" actId="1037"/>
-        <pc:sldMkLst>
-          <pc:docMk/>
-          <pc:sldMk cId="1889646820" sldId="704"/>
-        </pc:sldMkLst>
-        <pc:spChg chg="add mod">
-          <ac:chgData name="diagramador@aprovasim.com" userId="08c27f4fd777aeb1" providerId="LiveId" clId="{6DA82D89-F719-4B18-ABAA-0D43E56AF532}" dt="2026-02-12T13:48:30.936" v="4513" actId="1037"/>
-          <ac:spMkLst>
-            <pc:docMk/>
-            <pc:sldMk cId="1889646820" sldId="704"/>
-            <ac:spMk id="3" creationId="{F91679A2-5486-A936-A15D-F6D0399323B0}"/>
-          </ac:spMkLst>
-        </pc:spChg>
-        <pc:spChg chg="mod">
-          <ac:chgData name="diagramador@aprovasim.com" userId="08c27f4fd777aeb1" providerId="LiveId" clId="{6DA82D89-F719-4B18-ABAA-0D43E56AF532}" dt="2026-02-11T19:58:00.535" v="4240" actId="1076"/>
-          <ac:spMkLst>
-            <pc:docMk/>
-            <pc:sldMk cId="1889646820" sldId="704"/>
-            <ac:spMk id="5" creationId="{B9788270-B910-685E-288E-FB1FC23E53D6}"/>
-          </ac:spMkLst>
-        </pc:spChg>
-        <pc:spChg chg="mod">
-          <ac:chgData name="diagramador@aprovasim.com" userId="08c27f4fd777aeb1" providerId="LiveId" clId="{6DA82D89-F719-4B18-ABAA-0D43E56AF532}" dt="2026-02-11T19:57:55.280" v="4237" actId="1076"/>
-          <ac:spMkLst>
-            <pc:docMk/>
-            <pc:sldMk cId="1889646820" sldId="704"/>
-            <ac:spMk id="6" creationId="{9CC4FA51-2201-CA45-0AAE-1E17A5A0DADC}"/>
-          </ac:spMkLst>
-        </pc:spChg>
-        <pc:picChg chg="add mod">
-          <ac:chgData name="diagramador@aprovasim.com" userId="08c27f4fd777aeb1" providerId="LiveId" clId="{6DA82D89-F719-4B18-ABAA-0D43E56AF532}" dt="2026-02-11T20:53:50.890" v="4407" actId="732"/>
-          <ac:picMkLst>
-            <pc:docMk/>
-            <pc:sldMk cId="1889646820" sldId="704"/>
-            <ac:picMk id="19458" creationId="{2AA0D5AE-8719-F1DD-F6AB-5C0191EE74A5}"/>
-          </ac:picMkLst>
-        </pc:picChg>
-      </pc:sldChg>
-      <pc:sldChg chg="addSp delSp modSp add mod">
-        <pc:chgData name="diagramador@aprovasim.com" userId="08c27f4fd777aeb1" providerId="LiveId" clId="{6DA82D89-F719-4B18-ABAA-0D43E56AF532}" dt="2026-02-12T13:48:12.095" v="4488" actId="20577"/>
-        <pc:sldMkLst>
-          <pc:docMk/>
-          <pc:sldMk cId="3376136477" sldId="705"/>
-        </pc:sldMkLst>
-        <pc:spChg chg="add mod">
-          <ac:chgData name="diagramador@aprovasim.com" userId="08c27f4fd777aeb1" providerId="LiveId" clId="{6DA82D89-F719-4B18-ABAA-0D43E56AF532}" dt="2026-02-12T13:48:12.095" v="4488" actId="20577"/>
-          <ac:spMkLst>
-            <pc:docMk/>
-            <pc:sldMk cId="3376136477" sldId="705"/>
-            <ac:spMk id="3" creationId="{BE032622-BDCB-B4E8-9721-D1723473C143}"/>
-          </ac:spMkLst>
-        </pc:spChg>
-        <pc:spChg chg="mod">
-          <ac:chgData name="diagramador@aprovasim.com" userId="08c27f4fd777aeb1" providerId="LiveId" clId="{6DA82D89-F719-4B18-ABAA-0D43E56AF532}" dt="2026-02-12T13:47:37.350" v="4456" actId="1076"/>
-          <ac:spMkLst>
-            <pc:docMk/>
-            <pc:sldMk cId="3376136477" sldId="705"/>
-            <ac:spMk id="5" creationId="{E529B4A5-0DD7-A769-1EE5-0549B04AABD1}"/>
-          </ac:spMkLst>
-        </pc:spChg>
-        <pc:spChg chg="mod">
-          <ac:chgData name="diagramador@aprovasim.com" userId="08c27f4fd777aeb1" providerId="LiveId" clId="{6DA82D89-F719-4B18-ABAA-0D43E56AF532}" dt="2026-02-12T13:47:35.225" v="4455" actId="1076"/>
-          <ac:spMkLst>
-            <pc:docMk/>
-            <pc:sldMk cId="3376136477" sldId="705"/>
-            <ac:spMk id="6" creationId="{A4DCEB2A-F0AD-1F71-9ECF-23EE0E8FF504}"/>
-          </ac:spMkLst>
-        </pc:spChg>
-        <pc:picChg chg="add del mod">
-          <ac:chgData name="diagramador@aprovasim.com" userId="08c27f4fd777aeb1" providerId="LiveId" clId="{6DA82D89-F719-4B18-ABAA-0D43E56AF532}" dt="2026-02-11T20:54:50.350" v="4411" actId="478"/>
-          <ac:picMkLst>
-            <pc:docMk/>
-            <pc:sldMk cId="3376136477" sldId="705"/>
-            <ac:picMk id="20482" creationId="{A9B93986-8D6B-C5C0-18CD-10C85CA4A62B}"/>
-          </ac:picMkLst>
-        </pc:picChg>
-        <pc:picChg chg="add mod">
-          <ac:chgData name="diagramador@aprovasim.com" userId="08c27f4fd777aeb1" providerId="LiveId" clId="{6DA82D89-F719-4B18-ABAA-0D43E56AF532}" dt="2026-02-11T20:56:27.705" v="4416" actId="732"/>
-          <ac:picMkLst>
-            <pc:docMk/>
-            <pc:sldMk cId="3376136477" sldId="705"/>
-            <ac:picMk id="20484" creationId="{B94086EB-2EAB-5D89-B6A6-0D6D719A2459}"/>
+            <pc:sldMk cId="2235558883" sldId="728"/>
+            <ac:picMk id="2060" creationId="{AEDA09C3-22F2-5CCA-7B71-BCF3F55CC683}"/>
           </ac:picMkLst>
         </pc:picChg>
       </pc:sldChg>
@@ -1463,7 +297,7 @@
           <a:p>
             <a:fld id="{1536D114-1937-4C55-BF86-F4C020AE20B6}" type="datetimeFigureOut">
               <a:rPr lang="pt-BR" smtClean="0"/>
-              <a:t>07/04/2026</a:t>
+              <a:t>13/07/2026</a:t>
             </a:fld>
             <a:endParaRPr lang="pt-BR"/>
           </a:p>
@@ -1821,6 +655,121 @@
 </p:notes>
 </file>
 
+<file path=ppt/notesSlides/notesSlide2.xml><?xml version="1.0" encoding="utf-8"?>
+<p:notes xmlns:a="http://schemas.openxmlformats.org/drawingml/2006/main" xmlns:r="http://schemas.openxmlformats.org/officeDocument/2006/relationships" xmlns:p="http://schemas.openxmlformats.org/presentationml/2006/main">
+  <p:cSld>
+    <p:spTree>
+      <p:nvGrpSpPr>
+        <p:cNvPr id="1" name="">
+          <a:extLst>
+            <a:ext uri="{FF2B5EF4-FFF2-40B4-BE49-F238E27FC236}">
+              <a16:creationId xmlns:a16="http://schemas.microsoft.com/office/drawing/2014/main" id="{D4C8C7A1-612C-F87F-984A-715A43AEE4C9}"/>
+            </a:ext>
+          </a:extLst>
+        </p:cNvPr>
+        <p:cNvGrpSpPr/>
+        <p:nvPr/>
+      </p:nvGrpSpPr>
+      <p:grpSpPr>
+        <a:xfrm>
+          <a:off x="0" y="0"/>
+          <a:ext cx="0" cy="0"/>
+          <a:chOff x="0" y="0"/>
+          <a:chExt cx="0" cy="0"/>
+        </a:xfrm>
+      </p:grpSpPr>
+      <p:sp>
+        <p:nvSpPr>
+          <p:cNvPr id="2" name="Espaço Reservado para Imagem de Slide 1">
+            <a:extLst>
+              <a:ext uri="{FF2B5EF4-FFF2-40B4-BE49-F238E27FC236}">
+                <a16:creationId xmlns:a16="http://schemas.microsoft.com/office/drawing/2014/main" id="{1926DB7F-C176-419E-1374-8A3C5C627267}"/>
+              </a:ext>
+            </a:extLst>
+          </p:cNvPr>
+          <p:cNvSpPr>
+            <a:spLocks noGrp="1" noRot="1" noChangeAspect="1"/>
+          </p:cNvSpPr>
+          <p:nvPr>
+            <p:ph type="sldImg"/>
+          </p:nvPr>
+        </p:nvSpPr>
+        <p:spPr/>
+        <p:txBody>
+          <a:bodyPr/>
+          <a:lstStyle/>
+          <a:p>
+            <a:endParaRPr lang="pt-BR"/>
+          </a:p>
+        </p:txBody>
+      </p:sp>
+      <p:sp>
+        <p:nvSpPr>
+          <p:cNvPr id="3" name="Espaço Reservado para Anotações 2">
+            <a:extLst>
+              <a:ext uri="{FF2B5EF4-FFF2-40B4-BE49-F238E27FC236}">
+                <a16:creationId xmlns:a16="http://schemas.microsoft.com/office/drawing/2014/main" id="{07F191D5-2EA9-1684-DD2B-734F43C664C0}"/>
+              </a:ext>
+            </a:extLst>
+          </p:cNvPr>
+          <p:cNvSpPr>
+            <a:spLocks noGrp="1"/>
+          </p:cNvSpPr>
+          <p:nvPr>
+            <p:ph type="body" idx="1"/>
+          </p:nvPr>
+        </p:nvSpPr>
+        <p:spPr/>
+        <p:txBody>
+          <a:bodyPr/>
+          <a:lstStyle/>
+          <a:p>
+            <a:endParaRPr lang="pt-BR" dirty="0"/>
+          </a:p>
+        </p:txBody>
+      </p:sp>
+      <p:sp>
+        <p:nvSpPr>
+          <p:cNvPr id="4" name="Espaço Reservado para Número de Slide 3">
+            <a:extLst>
+              <a:ext uri="{FF2B5EF4-FFF2-40B4-BE49-F238E27FC236}">
+                <a16:creationId xmlns:a16="http://schemas.microsoft.com/office/drawing/2014/main" id="{E8889CD0-E13C-7F96-2834-B0FB2F6E8C75}"/>
+              </a:ext>
+            </a:extLst>
+          </p:cNvPr>
+          <p:cNvSpPr>
+            <a:spLocks noGrp="1"/>
+          </p:cNvSpPr>
+          <p:nvPr>
+            <p:ph type="sldNum" sz="quarter" idx="5"/>
+          </p:nvPr>
+        </p:nvSpPr>
+        <p:spPr/>
+        <p:txBody>
+          <a:bodyPr/>
+          <a:lstStyle/>
+          <a:p>
+            <a:fld id="{40F66082-62EF-4EF2-B22A-64B063CCC62A}" type="slidenum">
+              <a:rPr lang="pt-BR" smtClean="0"/>
+              <a:t>3</a:t>
+            </a:fld>
+            <a:endParaRPr lang="pt-BR"/>
+          </a:p>
+        </p:txBody>
+      </p:sp>
+    </p:spTree>
+    <p:extLst>
+      <p:ext uri="{BB962C8B-B14F-4D97-AF65-F5344CB8AC3E}">
+        <p14:creationId xmlns:p14="http://schemas.microsoft.com/office/powerpoint/2010/main" val="3934529961"/>
+      </p:ext>
+    </p:extLst>
+  </p:cSld>
+  <p:clrMapOvr>
+    <a:masterClrMapping/>
+  </p:clrMapOvr>
+</p:notes>
+</file>
+
 <file path=ppt/slideLayouts/slideLayout1.xml><?xml version="1.0" encoding="utf-8"?>
 <p:sldLayout xmlns:a="http://schemas.openxmlformats.org/drawingml/2006/main" xmlns:r="http://schemas.openxmlformats.org/officeDocument/2006/relationships" xmlns:p="http://schemas.openxmlformats.org/presentationml/2006/main" type="title" preserve="1">
   <p:cSld name="Slide de Título">
@@ -1952,7 +901,7 @@
           <a:p>
             <a:fld id="{46207116-AAC5-4A69-B50F-7FADCFFD150F}" type="datetimeFigureOut">
               <a:rPr lang="pt-BR" smtClean="0"/>
-              <a:t>07/04/2026</a:t>
+              <a:t>13/07/2026</a:t>
             </a:fld>
             <a:endParaRPr lang="pt-BR"/>
           </a:p>
@@ -2003,7 +952,7 @@
     </p:spTree>
     <p:extLst>
       <p:ext uri="{BB962C8B-B14F-4D97-AF65-F5344CB8AC3E}">
-        <p14:creationId xmlns:p14="http://schemas.microsoft.com/office/powerpoint/2010/main" val="925316927"/>
+        <p14:creationId xmlns:p14="http://schemas.microsoft.com/office/powerpoint/2010/main" val="3325193906"/>
       </p:ext>
     </p:extLst>
   </p:cSld>
@@ -2122,7 +1071,7 @@
           <a:p>
             <a:fld id="{46207116-AAC5-4A69-B50F-7FADCFFD150F}" type="datetimeFigureOut">
               <a:rPr lang="pt-BR" smtClean="0"/>
-              <a:t>07/04/2026</a:t>
+              <a:t>13/07/2026</a:t>
             </a:fld>
             <a:endParaRPr lang="pt-BR"/>
           </a:p>
@@ -2173,7 +1122,7 @@
     </p:spTree>
     <p:extLst>
       <p:ext uri="{BB962C8B-B14F-4D97-AF65-F5344CB8AC3E}">
-        <p14:creationId xmlns:p14="http://schemas.microsoft.com/office/powerpoint/2010/main" val="689479184"/>
+        <p14:creationId xmlns:p14="http://schemas.microsoft.com/office/powerpoint/2010/main" val="589480814"/>
       </p:ext>
     </p:extLst>
   </p:cSld>
@@ -2302,7 +1251,7 @@
           <a:p>
             <a:fld id="{46207116-AAC5-4A69-B50F-7FADCFFD150F}" type="datetimeFigureOut">
               <a:rPr lang="pt-BR" smtClean="0"/>
-              <a:t>07/04/2026</a:t>
+              <a:t>13/07/2026</a:t>
             </a:fld>
             <a:endParaRPr lang="pt-BR"/>
           </a:p>
@@ -2353,7 +1302,7 @@
     </p:spTree>
     <p:extLst>
       <p:ext uri="{BB962C8B-B14F-4D97-AF65-F5344CB8AC3E}">
-        <p14:creationId xmlns:p14="http://schemas.microsoft.com/office/powerpoint/2010/main" val="2911447672"/>
+        <p14:creationId xmlns:p14="http://schemas.microsoft.com/office/powerpoint/2010/main" val="704870641"/>
       </p:ext>
     </p:extLst>
   </p:cSld>
@@ -2472,7 +1421,7 @@
           <a:p>
             <a:fld id="{46207116-AAC5-4A69-B50F-7FADCFFD150F}" type="datetimeFigureOut">
               <a:rPr lang="pt-BR" smtClean="0"/>
-              <a:t>07/04/2026</a:t>
+              <a:t>13/07/2026</a:t>
             </a:fld>
             <a:endParaRPr lang="pt-BR"/>
           </a:p>
@@ -2523,7 +1472,7 @@
     </p:spTree>
     <p:extLst>
       <p:ext uri="{BB962C8B-B14F-4D97-AF65-F5344CB8AC3E}">
-        <p14:creationId xmlns:p14="http://schemas.microsoft.com/office/powerpoint/2010/main" val="3748661964"/>
+        <p14:creationId xmlns:p14="http://schemas.microsoft.com/office/powerpoint/2010/main" val="1214729251"/>
       </p:ext>
     </p:extLst>
   </p:cSld>
@@ -2606,7 +1555,7 @@
               <a:defRPr sz="2400">
                 <a:solidFill>
                   <a:schemeClr val="tx1">
-                    <a:tint val="75000"/>
+                    <a:tint val="82000"/>
                   </a:schemeClr>
                 </a:solidFill>
               </a:defRPr>
@@ -2616,7 +1565,7 @@
               <a:defRPr sz="2000">
                 <a:solidFill>
                   <a:schemeClr val="tx1">
-                    <a:tint val="75000"/>
+                    <a:tint val="82000"/>
                   </a:schemeClr>
                 </a:solidFill>
               </a:defRPr>
@@ -2626,7 +1575,7 @@
               <a:defRPr sz="1800">
                 <a:solidFill>
                   <a:schemeClr val="tx1">
-                    <a:tint val="75000"/>
+                    <a:tint val="82000"/>
                   </a:schemeClr>
                 </a:solidFill>
               </a:defRPr>
@@ -2636,7 +1585,7 @@
               <a:defRPr sz="1600">
                 <a:solidFill>
                   <a:schemeClr val="tx1">
-                    <a:tint val="75000"/>
+                    <a:tint val="82000"/>
                   </a:schemeClr>
                 </a:solidFill>
               </a:defRPr>
@@ -2646,7 +1595,7 @@
               <a:defRPr sz="1600">
                 <a:solidFill>
                   <a:schemeClr val="tx1">
-                    <a:tint val="75000"/>
+                    <a:tint val="82000"/>
                   </a:schemeClr>
                 </a:solidFill>
               </a:defRPr>
@@ -2656,7 +1605,7 @@
               <a:defRPr sz="1600">
                 <a:solidFill>
                   <a:schemeClr val="tx1">
-                    <a:tint val="75000"/>
+                    <a:tint val="82000"/>
                   </a:schemeClr>
                 </a:solidFill>
               </a:defRPr>
@@ -2666,7 +1615,7 @@
               <a:defRPr sz="1600">
                 <a:solidFill>
                   <a:schemeClr val="tx1">
-                    <a:tint val="75000"/>
+                    <a:tint val="82000"/>
                   </a:schemeClr>
                 </a:solidFill>
               </a:defRPr>
@@ -2676,7 +1625,7 @@
               <a:defRPr sz="1600">
                 <a:solidFill>
                   <a:schemeClr val="tx1">
-                    <a:tint val="75000"/>
+                    <a:tint val="82000"/>
                   </a:schemeClr>
                 </a:solidFill>
               </a:defRPr>
@@ -2686,7 +1635,7 @@
               <a:defRPr sz="1600">
                 <a:solidFill>
                   <a:schemeClr val="tx1">
-                    <a:tint val="75000"/>
+                    <a:tint val="82000"/>
                   </a:schemeClr>
                 </a:solidFill>
               </a:defRPr>
@@ -2718,7 +1667,7 @@
           <a:p>
             <a:fld id="{46207116-AAC5-4A69-B50F-7FADCFFD150F}" type="datetimeFigureOut">
               <a:rPr lang="pt-BR" smtClean="0"/>
-              <a:t>07/04/2026</a:t>
+              <a:t>13/07/2026</a:t>
             </a:fld>
             <a:endParaRPr lang="pt-BR"/>
           </a:p>
@@ -2769,7 +1718,7 @@
     </p:spTree>
     <p:extLst>
       <p:ext uri="{BB962C8B-B14F-4D97-AF65-F5344CB8AC3E}">
-        <p14:creationId xmlns:p14="http://schemas.microsoft.com/office/powerpoint/2010/main" val="4235861930"/>
+        <p14:creationId xmlns:p14="http://schemas.microsoft.com/office/powerpoint/2010/main" val="4126352538"/>
       </p:ext>
     </p:extLst>
   </p:cSld>
@@ -2950,7 +1899,7 @@
           <a:p>
             <a:fld id="{46207116-AAC5-4A69-B50F-7FADCFFD150F}" type="datetimeFigureOut">
               <a:rPr lang="pt-BR" smtClean="0"/>
-              <a:t>07/04/2026</a:t>
+              <a:t>13/07/2026</a:t>
             </a:fld>
             <a:endParaRPr lang="pt-BR"/>
           </a:p>
@@ -3001,7 +1950,7 @@
     </p:spTree>
     <p:extLst>
       <p:ext uri="{BB962C8B-B14F-4D97-AF65-F5344CB8AC3E}">
-        <p14:creationId xmlns:p14="http://schemas.microsoft.com/office/powerpoint/2010/main" val="1877465051"/>
+        <p14:creationId xmlns:p14="http://schemas.microsoft.com/office/powerpoint/2010/main" val="2189417397"/>
       </p:ext>
     </p:extLst>
   </p:cSld>
@@ -3317,7 +2266,7 @@
           <a:p>
             <a:fld id="{46207116-AAC5-4A69-B50F-7FADCFFD150F}" type="datetimeFigureOut">
               <a:rPr lang="pt-BR" smtClean="0"/>
-              <a:t>07/04/2026</a:t>
+              <a:t>13/07/2026</a:t>
             </a:fld>
             <a:endParaRPr lang="pt-BR"/>
           </a:p>
@@ -3368,7 +2317,7 @@
     </p:spTree>
     <p:extLst>
       <p:ext uri="{BB962C8B-B14F-4D97-AF65-F5344CB8AC3E}">
-        <p14:creationId xmlns:p14="http://schemas.microsoft.com/office/powerpoint/2010/main" val="1045249144"/>
+        <p14:creationId xmlns:p14="http://schemas.microsoft.com/office/powerpoint/2010/main" val="2888978039"/>
       </p:ext>
     </p:extLst>
   </p:cSld>
@@ -3435,7 +2384,7 @@
           <a:p>
             <a:fld id="{46207116-AAC5-4A69-B50F-7FADCFFD150F}" type="datetimeFigureOut">
               <a:rPr lang="pt-BR" smtClean="0"/>
-              <a:t>07/04/2026</a:t>
+              <a:t>13/07/2026</a:t>
             </a:fld>
             <a:endParaRPr lang="pt-BR"/>
           </a:p>
@@ -3486,7 +2435,7 @@
     </p:spTree>
     <p:extLst>
       <p:ext uri="{BB962C8B-B14F-4D97-AF65-F5344CB8AC3E}">
-        <p14:creationId xmlns:p14="http://schemas.microsoft.com/office/powerpoint/2010/main" val="1979030717"/>
+        <p14:creationId xmlns:p14="http://schemas.microsoft.com/office/powerpoint/2010/main" val="813820945"/>
       </p:ext>
     </p:extLst>
   </p:cSld>
@@ -3530,7 +2479,7 @@
           <a:p>
             <a:fld id="{46207116-AAC5-4A69-B50F-7FADCFFD150F}" type="datetimeFigureOut">
               <a:rPr lang="pt-BR" smtClean="0"/>
-              <a:t>07/04/2026</a:t>
+              <a:t>13/07/2026</a:t>
             </a:fld>
             <a:endParaRPr lang="pt-BR"/>
           </a:p>
@@ -3581,7 +2530,7 @@
     </p:spTree>
     <p:extLst>
       <p:ext uri="{BB962C8B-B14F-4D97-AF65-F5344CB8AC3E}">
-        <p14:creationId xmlns:p14="http://schemas.microsoft.com/office/powerpoint/2010/main" val="3301336714"/>
+        <p14:creationId xmlns:p14="http://schemas.microsoft.com/office/powerpoint/2010/main" val="3102538602"/>
       </p:ext>
     </p:extLst>
   </p:cSld>
@@ -3807,7 +2756,7 @@
           <a:p>
             <a:fld id="{46207116-AAC5-4A69-B50F-7FADCFFD150F}" type="datetimeFigureOut">
               <a:rPr lang="pt-BR" smtClean="0"/>
-              <a:t>07/04/2026</a:t>
+              <a:t>13/07/2026</a:t>
             </a:fld>
             <a:endParaRPr lang="pt-BR"/>
           </a:p>
@@ -3858,7 +2807,7 @@
     </p:spTree>
     <p:extLst>
       <p:ext uri="{BB962C8B-B14F-4D97-AF65-F5344CB8AC3E}">
-        <p14:creationId xmlns:p14="http://schemas.microsoft.com/office/powerpoint/2010/main" val="1820914983"/>
+        <p14:creationId xmlns:p14="http://schemas.microsoft.com/office/powerpoint/2010/main" val="840069483"/>
       </p:ext>
     </p:extLst>
   </p:cSld>
@@ -4064,7 +3013,7 @@
           <a:p>
             <a:fld id="{46207116-AAC5-4A69-B50F-7FADCFFD150F}" type="datetimeFigureOut">
               <a:rPr lang="pt-BR" smtClean="0"/>
-              <a:t>07/04/2026</a:t>
+              <a:t>13/07/2026</a:t>
             </a:fld>
             <a:endParaRPr lang="pt-BR"/>
           </a:p>
@@ -4115,7 +3064,7 @@
     </p:spTree>
     <p:extLst>
       <p:ext uri="{BB962C8B-B14F-4D97-AF65-F5344CB8AC3E}">
-        <p14:creationId xmlns:p14="http://schemas.microsoft.com/office/powerpoint/2010/main" val="737322641"/>
+        <p14:creationId xmlns:p14="http://schemas.microsoft.com/office/powerpoint/2010/main" val="718556581"/>
       </p:ext>
     </p:extLst>
   </p:cSld>
@@ -4129,18 +3078,9 @@
 <p:sldMaster xmlns:a="http://schemas.openxmlformats.org/drawingml/2006/main" xmlns:r="http://schemas.openxmlformats.org/officeDocument/2006/relationships" xmlns:p="http://schemas.openxmlformats.org/presentationml/2006/main">
   <p:cSld>
     <p:bg>
-      <p:bgPr>
-        <a:blipFill dpi="0" rotWithShape="1">
-          <a:blip r:embed="rId13">
-            <a:lum/>
-          </a:blip>
-          <a:srcRect/>
-          <a:stretch>
-            <a:fillRect/>
-          </a:stretch>
-        </a:blipFill>
-        <a:effectLst/>
-      </p:bgPr>
+      <p:bgRef idx="1001">
+        <a:schemeClr val="bg1"/>
+      </p:bgRef>
     </p:bg>
     <p:spTree>
       <p:nvGrpSpPr>
@@ -4277,7 +3217,7 @@
               <a:defRPr sz="1200">
                 <a:solidFill>
                   <a:schemeClr val="tx1">
-                    <a:tint val="75000"/>
+                    <a:tint val="82000"/>
                   </a:schemeClr>
                 </a:solidFill>
               </a:defRPr>
@@ -4286,7 +3226,7 @@
           <a:p>
             <a:fld id="{46207116-AAC5-4A69-B50F-7FADCFFD150F}" type="datetimeFigureOut">
               <a:rPr lang="pt-BR" smtClean="0"/>
-              <a:t>07/04/2026</a:t>
+              <a:t>13/07/2026</a:t>
             </a:fld>
             <a:endParaRPr lang="pt-BR"/>
           </a:p>
@@ -4318,7 +3258,7 @@
               <a:defRPr sz="1200">
                 <a:solidFill>
                   <a:schemeClr val="tx1">
-                    <a:tint val="75000"/>
+                    <a:tint val="82000"/>
                   </a:schemeClr>
                 </a:solidFill>
               </a:defRPr>
@@ -4355,7 +3295,7 @@
               <a:defRPr sz="1200">
                 <a:solidFill>
                   <a:schemeClr val="tx1">
-                    <a:tint val="75000"/>
+                    <a:tint val="82000"/>
                   </a:schemeClr>
                 </a:solidFill>
               </a:defRPr>
@@ -4373,23 +3313,23 @@
     </p:spTree>
     <p:extLst>
       <p:ext uri="{BB962C8B-B14F-4D97-AF65-F5344CB8AC3E}">
-        <p14:creationId xmlns:p14="http://schemas.microsoft.com/office/powerpoint/2010/main" val="1056473790"/>
+        <p14:creationId xmlns:p14="http://schemas.microsoft.com/office/powerpoint/2010/main" val="522269823"/>
       </p:ext>
     </p:extLst>
   </p:cSld>
   <p:clrMap bg1="lt1" tx1="dk1" bg2="lt2" tx2="dk2" accent1="accent1" accent2="accent2" accent3="accent3" accent4="accent4" accent5="accent5" accent6="accent6" hlink="hlink" folHlink="folHlink"/>
   <p:sldLayoutIdLst>
-    <p:sldLayoutId id="2147483697" r:id="rId1"/>
-    <p:sldLayoutId id="2147483698" r:id="rId2"/>
-    <p:sldLayoutId id="2147483699" r:id="rId3"/>
-    <p:sldLayoutId id="2147483700" r:id="rId4"/>
-    <p:sldLayoutId id="2147483701" r:id="rId5"/>
-    <p:sldLayoutId id="2147483702" r:id="rId6"/>
-    <p:sldLayoutId id="2147483703" r:id="rId7"/>
-    <p:sldLayoutId id="2147483704" r:id="rId8"/>
-    <p:sldLayoutId id="2147483705" r:id="rId9"/>
-    <p:sldLayoutId id="2147483706" r:id="rId10"/>
-    <p:sldLayoutId id="2147483707" r:id="rId11"/>
+    <p:sldLayoutId id="2147483721" r:id="rId1"/>
+    <p:sldLayoutId id="2147483722" r:id="rId2"/>
+    <p:sldLayoutId id="2147483723" r:id="rId3"/>
+    <p:sldLayoutId id="2147483724" r:id="rId4"/>
+    <p:sldLayoutId id="2147483725" r:id="rId5"/>
+    <p:sldLayoutId id="2147483726" r:id="rId6"/>
+    <p:sldLayoutId id="2147483727" r:id="rId7"/>
+    <p:sldLayoutId id="2147483728" r:id="rId8"/>
+    <p:sldLayoutId id="2147483729" r:id="rId9"/>
+    <p:sldLayoutId id="2147483730" r:id="rId10"/>
+    <p:sldLayoutId id="2147483731" r:id="rId11"/>
   </p:sldLayoutIdLst>
   <p:txStyles>
     <p:titleStyle>
@@ -4788,6 +3728,20 @@
 <file path=ppt/slides/slide2.xml><?xml version="1.0" encoding="utf-8"?>
 <p:sld xmlns:a="http://schemas.openxmlformats.org/drawingml/2006/main" xmlns:r="http://schemas.openxmlformats.org/officeDocument/2006/relationships" xmlns:p="http://schemas.openxmlformats.org/presentationml/2006/main">
   <p:cSld>
+    <p:bg>
+      <p:bgPr>
+        <a:blipFill dpi="0" rotWithShape="1">
+          <a:blip r:embed="rId3">
+            <a:lum/>
+          </a:blip>
+          <a:srcRect/>
+          <a:stretch>
+            <a:fillRect/>
+          </a:stretch>
+        </a:blipFill>
+        <a:effectLst/>
+      </p:bgPr>
+    </p:bg>
     <p:spTree>
       <p:nvGrpSpPr>
         <p:cNvPr id="1" name=""/>
@@ -4820,7 +3774,7 @@
         </p:nvSpPr>
         <p:spPr>
           <a:xfrm>
-            <a:off x="1472241" y="3142644"/>
+            <a:off x="1472240" y="2766218"/>
             <a:ext cx="9247517" cy="1325563"/>
           </a:xfrm>
         </p:spPr>
@@ -4836,20 +3790,31 @@
               </a:lnSpc>
             </a:pPr>
             <a:r>
-              <a:rPr lang="pt-BR" sz="5600" b="1" dirty="0">
+              <a:rPr lang="pt-BR" sz="6000" b="1" dirty="0">
                 <a:solidFill>
-                  <a:srgbClr val="DC3510"/>
+                  <a:srgbClr val="E7432D"/>
                 </a:solidFill>
                 <a:latin typeface="Inter Black" panose="02000A03000000020004" pitchFamily="50" charset="0"/>
                 <a:ea typeface="Inter Black" panose="02000A03000000020004" pitchFamily="50" charset="0"/>
                 <a:cs typeface="Inter Black" panose="02000A03000000020004" pitchFamily="50" charset="0"/>
               </a:rPr>
-              <a:t>ATUALIDADES </a:t>
+              <a:t>ATUALIDADES</a:t>
+            </a:r>
+            <a:r>
+              <a:rPr lang="pt-BR" sz="5600" b="1" dirty="0">
+                <a:solidFill>
+                  <a:schemeClr val="bg1"/>
+                </a:solidFill>
+                <a:latin typeface="Inter Black" panose="02000A03000000020004" pitchFamily="50" charset="0"/>
+                <a:ea typeface="Inter Black" panose="02000A03000000020004" pitchFamily="50" charset="0"/>
+                <a:cs typeface="Inter Black" panose="02000A03000000020004" pitchFamily="50" charset="0"/>
+              </a:rPr>
+              <a:t> </a:t>
             </a:r>
             <a:br>
               <a:rPr lang="pt-BR" sz="5600" b="1" dirty="0">
                 <a:solidFill>
-                  <a:srgbClr val="DC3510"/>
+                  <a:schemeClr val="bg1"/>
                 </a:solidFill>
                 <a:latin typeface="Inter Black" panose="02000A03000000020004" pitchFamily="50" charset="0"/>
                 <a:ea typeface="Inter Black" panose="02000A03000000020004" pitchFamily="50" charset="0"/>
@@ -4857,19 +3822,19 @@
               </a:rPr>
             </a:br>
             <a:r>
-              <a:rPr lang="pt-BR" sz="4900" b="1" dirty="0">
+              <a:rPr lang="pt-BR" b="1" dirty="0">
                 <a:solidFill>
-                  <a:srgbClr val="DC3510"/>
+                  <a:srgbClr val="E7432D"/>
                 </a:solidFill>
                 <a:latin typeface="Inter Black" panose="02000A03000000020004" pitchFamily="50" charset="0"/>
                 <a:ea typeface="Inter Black" panose="02000A03000000020004" pitchFamily="50" charset="0"/>
                 <a:cs typeface="Inter Black" panose="02000A03000000020004" pitchFamily="50" charset="0"/>
               </a:rPr>
-              <a:t>MARÇO 2026</a:t>
+              <a:t>MAIO 2026</a:t>
             </a:r>
             <a:endParaRPr lang="pt-BR" sz="5600" b="1" dirty="0">
               <a:solidFill>
-                <a:srgbClr val="FF0000"/>
+                <a:srgbClr val="E7432D"/>
               </a:solidFill>
               <a:latin typeface="Verdana" panose="020B0604030504040204" pitchFamily="34" charset="0"/>
               <a:ea typeface="Verdana" panose="020B0604030504040204" pitchFamily="34" charset="0"/>
@@ -4893,7 +3858,7 @@
         </p:nvSpPr>
         <p:spPr>
           <a:xfrm>
-            <a:off x="3046561" y="2390507"/>
+            <a:off x="3046561" y="4781282"/>
             <a:ext cx="6098876" cy="386023"/>
           </a:xfrm>
           <a:prstGeom prst="rect">
@@ -4925,7 +3890,7 @@
           </a:lstStyle>
           <a:p>
             <a:r>
-              <a:rPr lang="pt-BR" sz="4000" dirty="0">
+              <a:rPr lang="pt-BR" sz="2400" dirty="0">
                 <a:solidFill>
                   <a:schemeClr val="bg1">
                     <a:lumMod val="50000"/>
@@ -4934,7 +3899,7 @@
                 <a:latin typeface="Verdana" panose="020B0604030504040204" pitchFamily="34" charset="0"/>
                 <a:ea typeface="Verdana" panose="020B0604030504040204" pitchFamily="34" charset="0"/>
               </a:rPr>
-              <a:t>Max Engler</a:t>
+              <a:t>Prof. Max Engler</a:t>
             </a:r>
           </a:p>
         </p:txBody>
@@ -4952,14 +3917,20 @@
 </p:sld>
 </file>
 
-<file path=ppt/slides/slide4.xml><?xml version="1.0" encoding="utf-8"?>
+<file path=ppt/slides/slide3.xml><?xml version="1.0" encoding="utf-8"?>
 <p:sld xmlns:a="http://schemas.openxmlformats.org/drawingml/2006/main" xmlns:r="http://schemas.openxmlformats.org/officeDocument/2006/relationships" xmlns:p="http://schemas.openxmlformats.org/presentationml/2006/main">
   <p:cSld>
     <p:bg>
       <p:bgPr>
-        <a:solidFill>
-          <a:schemeClr val="bg1"/>
-        </a:solidFill>
+        <a:blipFill dpi="0" rotWithShape="1">
+          <a:blip r:embed="rId4">
+            <a:lum/>
+          </a:blip>
+          <a:srcRect/>
+          <a:stretch>
+            <a:fillRect/>
+          </a:stretch>
+        </a:blipFill>
         <a:effectLst/>
       </p:bgPr>
     </p:bg>
@@ -4968,7 +3939,7 @@
         <p:cNvPr id="1" name="">
           <a:extLst>
             <a:ext uri="{FF2B5EF4-FFF2-40B4-BE49-F238E27FC236}">
-              <a16:creationId xmlns:a16="http://schemas.microsoft.com/office/drawing/2014/main" id="{EC66D75A-144F-A7C8-0E12-0C61B795DDF6}"/>
+              <a16:creationId xmlns:a16="http://schemas.microsoft.com/office/drawing/2014/main" id="{3CF479ED-2499-2E02-D879-156E3F7FC5D4}"/>
             </a:ext>
           </a:extLst>
         </p:cNvPr>
@@ -4983,174 +3954,139 @@
           <a:chExt cx="0" cy="0"/>
         </a:xfrm>
       </p:grpSpPr>
-      <p:pic>
-        <p:nvPicPr>
-          <p:cNvPr id="3" name="Picture 2" descr="A deputados, Lula diz que convocar Guedes para o plenário é arriscado">
+      <p:sp>
+        <p:nvSpPr>
+          <p:cNvPr id="6" name="Retângulo 5">
             <a:extLst>
               <a:ext uri="{FF2B5EF4-FFF2-40B4-BE49-F238E27FC236}">
-                <a16:creationId xmlns:a16="http://schemas.microsoft.com/office/drawing/2014/main" id="{FD642594-9FC8-CD66-0C1F-A1CD178368CD}"/>
+                <a16:creationId xmlns:a16="http://schemas.microsoft.com/office/drawing/2014/main" id="{CAE89E0D-56A1-DE3E-87B6-12BD43B89CC5}"/>
               </a:ext>
             </a:extLst>
           </p:cNvPr>
-          <p:cNvPicPr>
-            <a:picLocks noChangeAspect="1" noChangeArrowheads="1"/>
-          </p:cNvPicPr>
+          <p:cNvSpPr/>
           <p:nvPr/>
-        </p:nvPicPr>
-        <p:blipFill rotWithShape="1">
-          <a:blip r:embed="rId2">
-            <a:extLst>
-              <a:ext uri="{28A0092B-C50C-407E-A947-70E740481C1C}">
-                <a14:useLocalDpi xmlns:a14="http://schemas.microsoft.com/office/drawing/2010/main" val="0"/>
-              </a:ext>
-            </a:extLst>
-          </a:blip>
-          <a:srcRect l="-1" r="22304"/>
-          <a:stretch>
-            <a:fillRect/>
-          </a:stretch>
-        </p:blipFill>
-        <p:spPr bwMode="auto">
+        </p:nvSpPr>
+        <p:spPr>
           <a:xfrm>
-            <a:off x="4195657" y="0"/>
-            <a:ext cx="7996343" cy="6858000"/>
+            <a:off x="515938" y="2539782"/>
+            <a:ext cx="5268636" cy="3734018"/>
           </a:xfrm>
           <a:prstGeom prst="rect">
             <a:avLst/>
           </a:prstGeom>
-          <a:noFill/>
-          <a:extLst>
-            <a:ext uri="{909E8E84-426E-40DD-AFC4-6F175D3DCCD1}">
-              <a14:hiddenFill xmlns:a14="http://schemas.microsoft.com/office/drawing/2010/main">
+        </p:spPr>
+        <p:txBody>
+          <a:bodyPr vert="horz" lIns="91440" tIns="45720" rIns="91440" bIns="45720" rtlCol="0">
+            <a:noAutofit/>
+          </a:bodyPr>
+          <a:lstStyle/>
+          <a:p>
+            <a:pPr indent="360000" algn="just">
+              <a:lnSpc>
+                <a:spcPct val="108000"/>
+              </a:lnSpc>
+              <a:spcAft>
+                <a:spcPts val="600"/>
+              </a:spcAft>
+            </a:pPr>
+            <a:r>
+              <a:rPr lang="pt-BR" dirty="0">
                 <a:solidFill>
-                  <a:srgbClr val="FFFFFF"/>
+                  <a:schemeClr val="bg2">
+                    <a:lumMod val="75000"/>
+                  </a:schemeClr>
                 </a:solidFill>
-              </a14:hiddenFill>
-            </a:ext>
-          </a:extLst>
-        </p:spPr>
-      </p:pic>
-      <p:sp>
-        <p:nvSpPr>
-          <p:cNvPr id="12" name="Freeform: Shape 11">
+                <a:latin typeface="Inter" panose="02000503000000020004" pitchFamily="2" charset="0"/>
+                <a:ea typeface="Inter" panose="02000503000000020004" pitchFamily="2" charset="0"/>
+                <a:cs typeface="Microsoft Sans Serif" panose="020B0604020202020204" pitchFamily="34" charset="0"/>
+              </a:rPr>
+              <a:t>Após mais de 20 anos de negociações, a parte comercial do acordo entre Mercosul e União Europeia entrou em vigor em maio de 2026. O tratado amplia o acesso de produtos brasileiros ao mercado europeu, mas também aumenta a concorrência para a indústria nacional. Além do impacto econômico, o acordo fortalece a posição estratégica do Mercosul em um cenário de disputa entre Estados Unidos e China.</a:t>
+            </a:r>
+          </a:p>
+        </p:txBody>
+      </p:sp>
+      <p:sp>
+        <p:nvSpPr>
+          <p:cNvPr id="5" name="Retângulo 4">
             <a:extLst>
               <a:ext uri="{FF2B5EF4-FFF2-40B4-BE49-F238E27FC236}">
-                <a16:creationId xmlns:a16="http://schemas.microsoft.com/office/drawing/2014/main" id="{5DF46162-4949-9E9B-4273-235707108ED4}"/>
-              </a:ext>
-              <a:ext uri="{C183D7F6-B498-43B3-948B-1728B52AA6E4}">
-                <adec:decorative xmlns:adec="http://schemas.microsoft.com/office/drawing/2017/decorative" val="1"/>
+                <a16:creationId xmlns:a16="http://schemas.microsoft.com/office/drawing/2014/main" id="{A6A2078D-83B0-A6D1-01AF-E1F984FDA87E}"/>
               </a:ext>
             </a:extLst>
           </p:cNvPr>
-          <p:cNvSpPr>
-            <a:spLocks noGrp="1" noRot="1" noChangeAspect="1" noMove="1" noResize="1" noEditPoints="1" noAdjustHandles="1" noChangeArrowheads="1" noChangeShapeType="1" noTextEdit="1"/>
-          </p:cNvSpPr>
-          <p:nvPr>
-            <p:extLst>
-              <p:ext uri="{386F3935-93C4-4BCD-93E2-E3B085C9AB24}">
-                <p16:designElem xmlns:p16="http://schemas.microsoft.com/office/powerpoint/2015/main" val="1"/>
-              </p:ext>
-            </p:extLst>
-          </p:nvPr>
+          <p:cNvSpPr/>
+          <p:nvPr/>
         </p:nvSpPr>
         <p:spPr>
-          <a:xfrm flipV="1">
-            <a:off x="0" y="-478"/>
-            <a:ext cx="8896786" cy="6858478"/>
+          <a:xfrm>
+            <a:off x="515938" y="1491445"/>
+            <a:ext cx="5268636" cy="736812"/>
           </a:xfrm>
-          <a:custGeom>
+          <a:prstGeom prst="rect">
             <a:avLst/>
-            <a:gdLst>
-              <a:gd name="connsiteX0" fmla="*/ 1472231 w 8896786"/>
-              <a:gd name="connsiteY0" fmla="*/ 6858478 h 6858478"/>
-              <a:gd name="connsiteX1" fmla="*/ 8896786 w 8896786"/>
-              <a:gd name="connsiteY1" fmla="*/ 6858478 h 6858478"/>
-              <a:gd name="connsiteX2" fmla="*/ 5720411 w 8896786"/>
-              <a:gd name="connsiteY2" fmla="*/ 0 h 6858478"/>
-              <a:gd name="connsiteX3" fmla="*/ 5714834 w 8896786"/>
-              <a:gd name="connsiteY3" fmla="*/ 0 h 6858478"/>
-              <a:gd name="connsiteX4" fmla="*/ 4648606 w 8896786"/>
-              <a:gd name="connsiteY4" fmla="*/ 0 h 6858478"/>
-              <a:gd name="connsiteX5" fmla="*/ 0 w 8896786"/>
-              <a:gd name="connsiteY5" fmla="*/ 0 h 6858478"/>
-              <a:gd name="connsiteX6" fmla="*/ 0 w 8896786"/>
-              <a:gd name="connsiteY6" fmla="*/ 6857915 h 6858478"/>
-              <a:gd name="connsiteX7" fmla="*/ 1472491 w 8896786"/>
-              <a:gd name="connsiteY7" fmla="*/ 6857915 h 6858478"/>
-            </a:gdLst>
-            <a:ahLst/>
-            <a:cxnLst>
-              <a:cxn ang="0">
-                <a:pos x="connsiteX0" y="connsiteY0"/>
-              </a:cxn>
-              <a:cxn ang="0">
-                <a:pos x="connsiteX1" y="connsiteY1"/>
-              </a:cxn>
-              <a:cxn ang="0">
-                <a:pos x="connsiteX2" y="connsiteY2"/>
-              </a:cxn>
-              <a:cxn ang="0">
-                <a:pos x="connsiteX3" y="connsiteY3"/>
-              </a:cxn>
-              <a:cxn ang="0">
-                <a:pos x="connsiteX4" y="connsiteY4"/>
-              </a:cxn>
-              <a:cxn ang="0">
-                <a:pos x="connsiteX5" y="connsiteY5"/>
-              </a:cxn>
-              <a:cxn ang="0">
-                <a:pos x="connsiteX6" y="connsiteY6"/>
-              </a:cxn>
-              <a:cxn ang="0">
-                <a:pos x="connsiteX7" y="connsiteY7"/>
-              </a:cxn>
-            </a:cxnLst>
-            <a:rect l="l" t="t" r="r" b="b"/>
-            <a:pathLst>
-              <a:path w="8896786" h="6858478">
-                <a:moveTo>
-                  <a:pt x="1472231" y="6858478"/>
-                </a:moveTo>
-                <a:lnTo>
-                  <a:pt x="8896786" y="6858478"/>
-                </a:lnTo>
-                <a:lnTo>
-                  <a:pt x="5720411" y="0"/>
-                </a:lnTo>
-                <a:lnTo>
-                  <a:pt x="5714834" y="0"/>
-                </a:lnTo>
-                <a:lnTo>
-                  <a:pt x="4648606" y="0"/>
-                </a:lnTo>
-                <a:lnTo>
-                  <a:pt x="0" y="0"/>
-                </a:lnTo>
-                <a:lnTo>
-                  <a:pt x="0" y="6857915"/>
-                </a:lnTo>
-                <a:lnTo>
-                  <a:pt x="1472491" y="6857915"/>
-                </a:lnTo>
-                <a:close/>
-              </a:path>
-            </a:pathLst>
-          </a:custGeom>
+          </a:prstGeom>
+        </p:spPr>
+        <p:txBody>
+          <a:bodyPr vert="horz" lIns="91440" tIns="45720" rIns="91440" bIns="45720" rtlCol="0" anchor="ctr">
+            <a:noAutofit/>
+          </a:bodyPr>
+          <a:lstStyle/>
+          <a:p>
+            <a:r>
+              <a:rPr lang="pt-BR" sz="3200" b="1" dirty="0">
+                <a:solidFill>
+                  <a:schemeClr val="bg2">
+                    <a:lumMod val="75000"/>
+                  </a:schemeClr>
+                </a:solidFill>
+                <a:latin typeface="Aptos ExtraBold" panose="020B0004020202020204" pitchFamily="34" charset="0"/>
+                <a:ea typeface="Verdana" panose="020B0604030504040204" pitchFamily="34" charset="0"/>
+              </a:rPr>
+              <a:t>Acordo Mercosul–União Europeia</a:t>
+            </a:r>
+          </a:p>
+        </p:txBody>
+      </p:sp>
+      <p:sp>
+        <p:nvSpPr>
+          <p:cNvPr id="3" name="Retângulo: Cantos Arredondados 2">
+            <a:extLst>
+              <a:ext uri="{FF2B5EF4-FFF2-40B4-BE49-F238E27FC236}">
+                <a16:creationId xmlns:a16="http://schemas.microsoft.com/office/drawing/2014/main" id="{A77F85BD-6AA1-5E41-EBFC-F84581D32800}"/>
+              </a:ext>
+            </a:extLst>
+          </p:cNvPr>
+          <p:cNvSpPr/>
+          <p:nvPr/>
+        </p:nvSpPr>
+        <p:spPr>
+          <a:xfrm>
+            <a:off x="515938" y="836613"/>
+            <a:ext cx="1293812" cy="343307"/>
+          </a:xfrm>
+          <a:prstGeom prst="roundRect">
+            <a:avLst>
+              <a:gd name="adj" fmla="val 24475"/>
+            </a:avLst>
+          </a:prstGeom>
           <a:solidFill>
-            <a:schemeClr val="bg1">
-              <a:lumMod val="85000"/>
-              <a:lumOff val="15000"/>
-              <a:alpha val="70000"/>
-            </a:schemeClr>
+            <a:srgbClr val="E7432D"/>
           </a:solidFill>
           <a:ln>
             <a:noFill/>
           </a:ln>
+          <a:effectLst>
+            <a:outerShdw blurRad="50800" dist="38100" dir="2700000" algn="tl" rotWithShape="0">
+              <a:prstClr val="black">
+                <a:alpha val="30000"/>
+              </a:prstClr>
+            </a:outerShdw>
+          </a:effectLst>
         </p:spPr>
         <p:style>
           <a:lnRef idx="2">
             <a:schemeClr val="accent1">
-              <a:shade val="50000"/>
+              <a:shade val="15000"/>
             </a:schemeClr>
           </a:lnRef>
           <a:fillRef idx="1">
@@ -5164,438 +4100,85 @@
           </a:fontRef>
         </p:style>
         <p:txBody>
-          <a:bodyPr wrap="square" rtlCol="0" anchor="ctr">
-            <a:noAutofit/>
-          </a:bodyPr>
-          <a:lstStyle/>
-          <a:p>
-            <a:pPr marL="0" marR="0" lvl="0" indent="0" algn="ctr" defTabSz="914400" rtl="0" eaLnBrk="1" fontAlgn="auto" latinLnBrk="0" hangingPunct="1">
-              <a:lnSpc>
-                <a:spcPct val="100000"/>
-              </a:lnSpc>
-              <a:spcBef>
-                <a:spcPts val="0"/>
-              </a:spcBef>
-              <a:spcAft>
-                <a:spcPts val="0"/>
-              </a:spcAft>
-              <a:buClrTx/>
-              <a:buSzTx/>
-              <a:buFontTx/>
-              <a:buNone/>
-              <a:tabLst/>
-              <a:defRPr/>
-            </a:pPr>
-            <a:endParaRPr kumimoji="0" lang="en-US" sz="1800" b="0" i="0" u="none" strike="noStrike" kern="1200" cap="none" spc="0" normalizeH="0" baseline="0" noProof="0">
-              <a:ln>
-                <a:noFill/>
-              </a:ln>
-              <a:solidFill>
-                <a:prstClr val="white"/>
-              </a:solidFill>
-              <a:effectLst/>
-              <a:uLnTx/>
-              <a:uFillTx/>
-              <a:latin typeface="Calibri" panose="020F0502020204030204"/>
-              <a:ea typeface="+mn-ea"/>
-              <a:cs typeface="+mn-cs"/>
-            </a:endParaRPr>
-          </a:p>
-        </p:txBody>
-      </p:sp>
-      <p:sp>
-        <p:nvSpPr>
-          <p:cNvPr id="14" name="Freeform: Shape 13">
+          <a:bodyPr rtlCol="0" anchor="ctr"/>
+          <a:lstStyle/>
+          <a:p>
+            <a:r>
+              <a:rPr lang="pt-BR" sz="1600" b="1" dirty="0">
+                <a:solidFill>
+                  <a:schemeClr val="tx1"/>
+                </a:solidFill>
+                <a:sym typeface="Symbol" panose="05050102010706020507" pitchFamily="18" charset="2"/>
+              </a:rPr>
+              <a:t>  </a:t>
+            </a:r>
+            <a:r>
+              <a:rPr lang="pt-BR" sz="1600" b="1" dirty="0">
+                <a:solidFill>
+                  <a:schemeClr val="tx1"/>
+                </a:solidFill>
+              </a:rPr>
+              <a:t>BRASIL</a:t>
+            </a:r>
+          </a:p>
+        </p:txBody>
+      </p:sp>
+      <p:pic>
+        <p:nvPicPr>
+          <p:cNvPr id="2060" name="Picture 12" descr="CEBRI-Revista | Brasil e União Europeia: situação atual das relações e  perspectivas">
             <a:extLst>
               <a:ext uri="{FF2B5EF4-FFF2-40B4-BE49-F238E27FC236}">
-                <a16:creationId xmlns:a16="http://schemas.microsoft.com/office/drawing/2014/main" id="{3D199B99-02DA-85A9-3F8C-6023685B6B0F}"/>
-              </a:ext>
-              <a:ext uri="{C183D7F6-B498-43B3-948B-1728B52AA6E4}">
-                <adec:decorative xmlns:adec="http://schemas.microsoft.com/office/drawing/2017/decorative" val="1"/>
-              </a:ext>
-            </a:extLst>
-          </p:cNvPr>
-          <p:cNvSpPr>
-            <a:spLocks noGrp="1" noRot="1" noChangeAspect="1" noMove="1" noResize="1" noEditPoints="1" noAdjustHandles="1" noChangeArrowheads="1" noChangeShapeType="1" noTextEdit="1"/>
-          </p:cNvSpPr>
-          <p:nvPr>
-            <p:extLst>
-              <p:ext uri="{386F3935-93C4-4BCD-93E2-E3B085C9AB24}">
-                <p16:designElem xmlns:p16="http://schemas.microsoft.com/office/powerpoint/2015/main" val="1"/>
-              </p:ext>
-            </p:extLst>
-          </p:nvPr>
-        </p:nvSpPr>
-        <p:spPr>
-          <a:xfrm flipV="1">
-            <a:off x="0" y="-479"/>
-            <a:ext cx="8096249" cy="6858479"/>
-          </a:xfrm>
-          <a:custGeom>
-            <a:avLst/>
-            <a:gdLst>
-              <a:gd name="connsiteX0" fmla="*/ 0 w 8096249"/>
-              <a:gd name="connsiteY0" fmla="*/ 6858479 h 6858479"/>
-              <a:gd name="connsiteX1" fmla="*/ 2130297 w 8096249"/>
-              <a:gd name="connsiteY1" fmla="*/ 6858479 h 6858479"/>
-              <a:gd name="connsiteX2" fmla="*/ 2130297 w 8096249"/>
-              <a:gd name="connsiteY2" fmla="*/ 6858478 h 6858479"/>
-              <a:gd name="connsiteX3" fmla="*/ 8096249 w 8096249"/>
-              <a:gd name="connsiteY3" fmla="*/ 6858478 h 6858479"/>
-              <a:gd name="connsiteX4" fmla="*/ 4919874 w 8096249"/>
-              <a:gd name="connsiteY4" fmla="*/ 0 h 6858479"/>
-              <a:gd name="connsiteX5" fmla="*/ 4914297 w 8096249"/>
-              <a:gd name="connsiteY5" fmla="*/ 0 h 6858479"/>
-              <a:gd name="connsiteX6" fmla="*/ 3848069 w 8096249"/>
-              <a:gd name="connsiteY6" fmla="*/ 0 h 6858479"/>
-              <a:gd name="connsiteX7" fmla="*/ 18197 w 8096249"/>
-              <a:gd name="connsiteY7" fmla="*/ 0 h 6858479"/>
-              <a:gd name="connsiteX8" fmla="*/ 18197 w 8096249"/>
-              <a:gd name="connsiteY8" fmla="*/ 479 h 6858479"/>
-              <a:gd name="connsiteX9" fmla="*/ 0 w 8096249"/>
-              <a:gd name="connsiteY9" fmla="*/ 479 h 6858479"/>
-            </a:gdLst>
-            <a:ahLst/>
-            <a:cxnLst>
-              <a:cxn ang="0">
-                <a:pos x="connsiteX0" y="connsiteY0"/>
-              </a:cxn>
-              <a:cxn ang="0">
-                <a:pos x="connsiteX1" y="connsiteY1"/>
-              </a:cxn>
-              <a:cxn ang="0">
-                <a:pos x="connsiteX2" y="connsiteY2"/>
-              </a:cxn>
-              <a:cxn ang="0">
-                <a:pos x="connsiteX3" y="connsiteY3"/>
-              </a:cxn>
-              <a:cxn ang="0">
-                <a:pos x="connsiteX4" y="connsiteY4"/>
-              </a:cxn>
-              <a:cxn ang="0">
-                <a:pos x="connsiteX5" y="connsiteY5"/>
-              </a:cxn>
-              <a:cxn ang="0">
-                <a:pos x="connsiteX6" y="connsiteY6"/>
-              </a:cxn>
-              <a:cxn ang="0">
-                <a:pos x="connsiteX7" y="connsiteY7"/>
-              </a:cxn>
-              <a:cxn ang="0">
-                <a:pos x="connsiteX8" y="connsiteY8"/>
-              </a:cxn>
-              <a:cxn ang="0">
-                <a:pos x="connsiteX9" y="connsiteY9"/>
-              </a:cxn>
-            </a:cxnLst>
-            <a:rect l="l" t="t" r="r" b="b"/>
-            <a:pathLst>
-              <a:path w="8096249" h="6858479">
-                <a:moveTo>
-                  <a:pt x="0" y="6858479"/>
-                </a:moveTo>
-                <a:lnTo>
-                  <a:pt x="2130297" y="6858479"/>
-                </a:lnTo>
-                <a:lnTo>
-                  <a:pt x="2130297" y="6858478"/>
-                </a:lnTo>
-                <a:lnTo>
-                  <a:pt x="8096249" y="6858478"/>
-                </a:lnTo>
-                <a:lnTo>
-                  <a:pt x="4919874" y="0"/>
-                </a:lnTo>
-                <a:lnTo>
-                  <a:pt x="4914297" y="0"/>
-                </a:lnTo>
-                <a:lnTo>
-                  <a:pt x="3848069" y="0"/>
-                </a:lnTo>
-                <a:lnTo>
-                  <a:pt x="18197" y="0"/>
-                </a:lnTo>
-                <a:lnTo>
-                  <a:pt x="18197" y="479"/>
-                </a:lnTo>
-                <a:lnTo>
-                  <a:pt x="0" y="479"/>
-                </a:lnTo>
-                <a:close/>
-              </a:path>
-            </a:pathLst>
-          </a:custGeom>
-          <a:solidFill>
-            <a:schemeClr val="bg1">
-              <a:lumMod val="85000"/>
-              <a:lumOff val="15000"/>
-            </a:schemeClr>
-          </a:solidFill>
-          <a:ln>
-            <a:noFill/>
-          </a:ln>
-        </p:spPr>
-        <p:style>
-          <a:lnRef idx="2">
-            <a:schemeClr val="accent1">
-              <a:shade val="50000"/>
-            </a:schemeClr>
-          </a:lnRef>
-          <a:fillRef idx="1">
-            <a:schemeClr val="accent1"/>
-          </a:fillRef>
-          <a:effectRef idx="0">
-            <a:schemeClr val="accent1"/>
-          </a:effectRef>
-          <a:fontRef idx="minor">
-            <a:schemeClr val="lt1"/>
-          </a:fontRef>
-        </p:style>
-        <p:txBody>
-          <a:bodyPr wrap="square" rtlCol="0" anchor="ctr">
-            <a:noAutofit/>
-          </a:bodyPr>
-          <a:lstStyle/>
-          <a:p>
-            <a:pPr marL="0" marR="0" lvl="0" indent="0" algn="ctr" defTabSz="914400" rtl="0" eaLnBrk="1" fontAlgn="auto" latinLnBrk="0" hangingPunct="1">
-              <a:lnSpc>
-                <a:spcPct val="100000"/>
-              </a:lnSpc>
-              <a:spcBef>
-                <a:spcPts val="0"/>
-              </a:spcBef>
-              <a:spcAft>
-                <a:spcPts val="0"/>
-              </a:spcAft>
-              <a:buClrTx/>
-              <a:buSzTx/>
-              <a:buFontTx/>
-              <a:buNone/>
-              <a:tabLst/>
-              <a:defRPr/>
-            </a:pPr>
-            <a:endParaRPr kumimoji="0" lang="en-US" sz="1800" b="0" i="0" u="none" strike="noStrike" kern="1200" cap="none" spc="0" normalizeH="0" baseline="0" noProof="0">
-              <a:ln>
-                <a:noFill/>
-              </a:ln>
-              <a:solidFill>
-                <a:prstClr val="white"/>
-              </a:solidFill>
-              <a:effectLst/>
-              <a:uLnTx/>
-              <a:uFillTx/>
-              <a:latin typeface="Calibri" panose="020F0502020204030204"/>
-              <a:ea typeface="+mn-ea"/>
-              <a:cs typeface="+mn-cs"/>
-            </a:endParaRPr>
-          </a:p>
-        </p:txBody>
-      </p:sp>
-      <p:sp>
-        <p:nvSpPr>
-          <p:cNvPr id="6" name="Retângulo 5">
-            <a:extLst>
-              <a:ext uri="{FF2B5EF4-FFF2-40B4-BE49-F238E27FC236}">
-                <a16:creationId xmlns:a16="http://schemas.microsoft.com/office/drawing/2014/main" id="{46FC4CE2-33E5-6D0F-F849-E8AEF23B4B2F}"/>
-              </a:ext>
-            </a:extLst>
-          </p:cNvPr>
-          <p:cNvSpPr/>
-          <p:nvPr/>
-        </p:nvSpPr>
-        <p:spPr>
-          <a:xfrm>
-            <a:off x="423322" y="2218412"/>
-            <a:ext cx="5182348" cy="3877587"/>
-          </a:xfrm>
-          <a:prstGeom prst="rect">
-            <a:avLst/>
-          </a:prstGeom>
-        </p:spPr>
-        <p:txBody>
-          <a:bodyPr vert="horz" lIns="91440" tIns="45720" rIns="91440" bIns="45720" rtlCol="0">
-            <a:noAutofit/>
-          </a:bodyPr>
-          <a:lstStyle/>
-          <a:p>
-            <a:pPr marL="285750" indent="-285750" algn="just">
-              <a:lnSpc>
-                <a:spcPct val="108000"/>
-              </a:lnSpc>
-              <a:spcAft>
-                <a:spcPts val="600"/>
-              </a:spcAft>
-              <a:buFont typeface="Arial" panose="020B0604020202020204" pitchFamily="34" charset="0"/>
-              <a:buChar char="•"/>
-            </a:pPr>
-            <a:r>
-              <a:rPr lang="pt-BR" spc="-20" dirty="0">
-                <a:latin typeface="Verdana" panose="020B0604030504040204" pitchFamily="34" charset="0"/>
-                <a:ea typeface="Verdana" panose="020B0604030504040204" pitchFamily="34" charset="0"/>
-              </a:rPr>
-              <a:t>Lula afirmou que o Brasil precisa se preparar melhor.</a:t>
-            </a:r>
-          </a:p>
-          <a:p>
-            <a:pPr marL="285750" indent="-285750" algn="just">
-              <a:lnSpc>
-                <a:spcPct val="108000"/>
-              </a:lnSpc>
-              <a:spcAft>
-                <a:spcPts val="600"/>
-              </a:spcAft>
-              <a:buFont typeface="Arial" panose="020B0604020202020204" pitchFamily="34" charset="0"/>
-              <a:buChar char="•"/>
-            </a:pPr>
-            <a:r>
-              <a:rPr lang="pt-BR" spc="-20" dirty="0">
-                <a:latin typeface="Verdana" panose="020B0604030504040204" pitchFamily="34" charset="0"/>
-                <a:ea typeface="Verdana" panose="020B0604030504040204" pitchFamily="34" charset="0"/>
-              </a:rPr>
-              <a:t>Declaração ocorre em cenário de instabilidade global.</a:t>
-            </a:r>
-          </a:p>
-          <a:p>
-            <a:pPr marL="285750" indent="-285750" algn="just">
-              <a:lnSpc>
-                <a:spcPct val="108000"/>
-              </a:lnSpc>
-              <a:spcAft>
-                <a:spcPts val="600"/>
-              </a:spcAft>
-              <a:buFont typeface="Arial" panose="020B0604020202020204" pitchFamily="34" charset="0"/>
-              <a:buChar char="•"/>
-            </a:pPr>
-            <a:r>
-              <a:rPr lang="pt-BR" spc="-20" dirty="0">
-                <a:latin typeface="Verdana" panose="020B0604030504040204" pitchFamily="34" charset="0"/>
-                <a:ea typeface="Verdana" panose="020B0604030504040204" pitchFamily="34" charset="0"/>
-              </a:rPr>
-              <a:t>Tema envolve Forças Armadas e capacidade de defesa.</a:t>
-            </a:r>
-          </a:p>
-          <a:p>
-            <a:pPr marL="285750" indent="-285750" algn="just">
-              <a:lnSpc>
-                <a:spcPct val="108000"/>
-              </a:lnSpc>
-              <a:spcAft>
-                <a:spcPts val="600"/>
-              </a:spcAft>
-              <a:buFont typeface="Arial" panose="020B0604020202020204" pitchFamily="34" charset="0"/>
-              <a:buChar char="•"/>
-            </a:pPr>
-            <a:r>
-              <a:rPr lang="pt-BR" spc="-20" dirty="0">
-                <a:latin typeface="Verdana" panose="020B0604030504040204" pitchFamily="34" charset="0"/>
-                <a:ea typeface="Verdana" panose="020B0604030504040204" pitchFamily="34" charset="0"/>
-              </a:rPr>
-              <a:t>Países com recursos naturais ganham relevância estratégica.</a:t>
-            </a:r>
-          </a:p>
-          <a:p>
-            <a:pPr marL="285750" indent="-285750" algn="just">
-              <a:lnSpc>
-                <a:spcPct val="108000"/>
-              </a:lnSpc>
-              <a:spcAft>
-                <a:spcPts val="600"/>
-              </a:spcAft>
-              <a:buFont typeface="Arial" panose="020B0604020202020204" pitchFamily="34" charset="0"/>
-              <a:buChar char="•"/>
-            </a:pPr>
-            <a:r>
-              <a:rPr lang="pt-BR" spc="-20" dirty="0">
-                <a:latin typeface="Verdana" panose="020B0604030504040204" pitchFamily="34" charset="0"/>
-                <a:ea typeface="Verdana" panose="020B0604030504040204" pitchFamily="34" charset="0"/>
-              </a:rPr>
-              <a:t>Debate sobre autonomia e segurança nacional se amplia.</a:t>
-            </a:r>
-            <a:endParaRPr lang="pt-BR" spc="-30" dirty="0">
-              <a:latin typeface="Verdana" panose="020B0604030504040204" pitchFamily="34" charset="0"/>
-              <a:ea typeface="Verdana" panose="020B0604030504040204" pitchFamily="34" charset="0"/>
-            </a:endParaRPr>
-          </a:p>
-        </p:txBody>
-      </p:sp>
-      <p:pic>
-        <p:nvPicPr>
-          <p:cNvPr id="2" name="Imagem 1" descr="Desenho com traços pretos em fundo branco&#10;&#10;Descrição gerada automaticamente com confiança média">
-            <a:extLst>
-              <a:ext uri="{FF2B5EF4-FFF2-40B4-BE49-F238E27FC236}">
-                <a16:creationId xmlns:a16="http://schemas.microsoft.com/office/drawing/2014/main" id="{8190944F-2ADF-F67E-B846-BD6024A3B03A}"/>
+                <a16:creationId xmlns:a16="http://schemas.microsoft.com/office/drawing/2014/main" id="{AEDA09C3-22F2-5CCA-7B71-BCF3F55CC683}"/>
               </a:ext>
             </a:extLst>
           </p:cNvPr>
           <p:cNvPicPr>
-            <a:picLocks noChangeAspect="1"/>
+            <a:picLocks noChangeAspect="1" noChangeArrowheads="1"/>
           </p:cNvPicPr>
           <p:nvPr/>
         </p:nvPicPr>
-        <p:blipFill>
-          <a:blip r:embed="rId3">
+        <p:blipFill rotWithShape="1">
+          <a:blip r:embed="rId5">
+            <a:alphaModFix/>
             <a:extLst>
               <a:ext uri="{28A0092B-C50C-407E-A947-70E740481C1C}">
                 <a14:useLocalDpi xmlns:a14="http://schemas.microsoft.com/office/drawing/2010/main" val="0"/>
               </a:ext>
             </a:extLst>
           </a:blip>
+          <a:srcRect l="21315" r="4016"/>
           <a:stretch>
             <a:fillRect/>
           </a:stretch>
         </p:blipFill>
-        <p:spPr>
+        <p:spPr bwMode="auto">
           <a:xfrm>
-            <a:off x="423333" y="249490"/>
-            <a:ext cx="1246848" cy="242416"/>
+            <a:off x="5784574" y="728663"/>
+            <a:ext cx="6407426" cy="6129337"/>
           </a:xfrm>
           <a:prstGeom prst="rect">
             <a:avLst/>
           </a:prstGeom>
+          <a:effectLst>
+            <a:innerShdw blurRad="850900" dist="762000" dir="10800000">
+              <a:srgbClr val="FFFFFD"/>
+            </a:innerShdw>
+          </a:effectLst>
+          <a:extLst>
+            <a:ext uri="{909E8E84-426E-40DD-AFC4-6F175D3DCCD1}">
+              <a14:hiddenFill xmlns:a14="http://schemas.microsoft.com/office/drawing/2010/main">
+                <a:solidFill>
+                  <a:srgbClr val="FFFFFF"/>
+                </a:solidFill>
+              </a14:hiddenFill>
+            </a:ext>
+          </a:extLst>
         </p:spPr>
       </p:pic>
-      <p:sp>
-        <p:nvSpPr>
-          <p:cNvPr id="5" name="Retângulo 4">
-            <a:extLst>
-              <a:ext uri="{FF2B5EF4-FFF2-40B4-BE49-F238E27FC236}">
-                <a16:creationId xmlns:a16="http://schemas.microsoft.com/office/drawing/2014/main" id="{A51601C8-A419-43E8-27FA-C8417B406F14}"/>
-              </a:ext>
-            </a:extLst>
-          </p:cNvPr>
-          <p:cNvSpPr/>
-          <p:nvPr/>
-        </p:nvSpPr>
-        <p:spPr>
-          <a:xfrm>
-            <a:off x="423321" y="905569"/>
-            <a:ext cx="6453729" cy="979468"/>
-          </a:xfrm>
-          <a:prstGeom prst="rect">
-            <a:avLst/>
-          </a:prstGeom>
-        </p:spPr>
-        <p:txBody>
-          <a:bodyPr vert="horz" lIns="91440" tIns="45720" rIns="91440" bIns="45720" rtlCol="0" anchor="ctr">
-            <a:noAutofit/>
-          </a:bodyPr>
-          <a:lstStyle/>
-          <a:p>
-            <a:pPr algn="just"/>
-            <a:r>
-              <a:rPr lang="pt-BR" sz="2400" b="1" dirty="0">
-                <a:latin typeface="Verdana" panose="020B0604030504040204" pitchFamily="34" charset="0"/>
-                <a:ea typeface="Verdana" panose="020B0604030504040204" pitchFamily="34" charset="0"/>
-              </a:rPr>
-              <a:t>LULA ALERTA SOBRE DEFESA E SOBERANIA NACIONAL</a:t>
-            </a:r>
-          </a:p>
-        </p:txBody>
-      </p:sp>
     </p:spTree>
     <p:extLst>
       <p:ext uri="{BB962C8B-B14F-4D97-AF65-F5344CB8AC3E}">
-        <p14:creationId xmlns:p14="http://schemas.microsoft.com/office/powerpoint/2010/main" val="1999350397"/>
+        <p14:creationId xmlns:p14="http://schemas.microsoft.com/office/powerpoint/2010/main" val="2235558883"/>
       </p:ext>
     </p:extLst>
   </p:cSld>
@@ -5614,7 +4197,7 @@
 <file path=ppt/theme/theme1.xml><?xml version="1.0" encoding="utf-8"?>
 <a:theme xmlns:a="http://schemas.openxmlformats.org/drawingml/2006/main" name="Office Theme">
   <a:themeElements>
-    <a:clrScheme name="Tema do Office">
+    <a:clrScheme name="Office 2013 - 2022">
       <a:dk1>
         <a:sysClr val="windowText" lastClr="000000"/>
       </a:dk1>
@@ -5654,7 +4237,7 @@
     </a:clrScheme>
     <a:fontScheme name="Tema do Office">
       <a:majorFont>
-        <a:latin typeface="Calibri Light" panose="020F0302020204030204"/>
+        <a:latin typeface="Aptos Display" panose="02110004020202020204"/>
         <a:ea typeface=""/>
         <a:cs typeface=""/>
         <a:font script="Jpan" typeface="游ゴシック Light"/>
@@ -5687,9 +4270,26 @@
         <a:font script="Viet" typeface="Times New Roman"/>
         <a:font script="Uigh" typeface="Microsoft Uighur"/>
         <a:font script="Geor" typeface="Sylfaen"/>
+        <a:font script="Armn" typeface="Arial"/>
+        <a:font script="Bugi" typeface="Leelawadee UI"/>
+        <a:font script="Bopo" typeface="Microsoft JhengHei"/>
+        <a:font script="Java" typeface="Javanese Text"/>
+        <a:font script="Lisu" typeface="Segoe UI"/>
+        <a:font script="Mymr" typeface="Myanmar Text"/>
+        <a:font script="Nkoo" typeface="Ebrima"/>
+        <a:font script="Olck" typeface="Nirmala UI"/>
+        <a:font script="Osma" typeface="Ebrima"/>
+        <a:font script="Phag" typeface="Phagspa"/>
+        <a:font script="Syrn" typeface="Estrangelo Edessa"/>
+        <a:font script="Syrj" typeface="Estrangelo Edessa"/>
+        <a:font script="Syre" typeface="Estrangelo Edessa"/>
+        <a:font script="Sora" typeface="Nirmala UI"/>
+        <a:font script="Tale" typeface="Microsoft Tai Le"/>
+        <a:font script="Talu" typeface="Microsoft New Tai Lue"/>
+        <a:font script="Tfng" typeface="Ebrima"/>
       </a:majorFont>
       <a:minorFont>
-        <a:latin typeface="Calibri" panose="020F0502020204030204"/>
+        <a:latin typeface="Aptos" panose="02110004020202020204"/>
         <a:ea typeface=""/>
         <a:cs typeface=""/>
         <a:font script="Jpan" typeface="游ゴシック"/>
@@ -5722,6 +4322,23 @@
         <a:font script="Viet" typeface="Arial"/>
         <a:font script="Uigh" typeface="Microsoft Uighur"/>
         <a:font script="Geor" typeface="Sylfaen"/>
+        <a:font script="Armn" typeface="Arial"/>
+        <a:font script="Bugi" typeface="Leelawadee UI"/>
+        <a:font script="Bopo" typeface="Microsoft JhengHei"/>
+        <a:font script="Java" typeface="Javanese Text"/>
+        <a:font script="Lisu" typeface="Segoe UI"/>
+        <a:font script="Mymr" typeface="Myanmar Text"/>
+        <a:font script="Nkoo" typeface="Ebrima"/>
+        <a:font script="Olck" typeface="Nirmala UI"/>
+        <a:font script="Osma" typeface="Ebrima"/>
+        <a:font script="Phag" typeface="Phagspa"/>
+        <a:font script="Syrn" typeface="Estrangelo Edessa"/>
+        <a:font script="Syrj" typeface="Estrangelo Edessa"/>
+        <a:font script="Syre" typeface="Estrangelo Edessa"/>
+        <a:font script="Sora" typeface="Nirmala UI"/>
+        <a:font script="Tale" typeface="Microsoft Tai Le"/>
+        <a:font script="Talu" typeface="Microsoft New Tai Lue"/>
+        <a:font script="Tfng" typeface="Ebrima"/>
       </a:minorFont>
     </a:fontScheme>
     <a:fmtScheme name="Tema do Office">
@@ -5783,13 +4400,6 @@
         </a:gradFill>
       </a:fillStyleLst>
       <a:lnStyleLst>
-        <a:ln w="6350" cap="flat" cmpd="sng" algn="ctr">
-          <a:solidFill>
-            <a:schemeClr val="phClr"/>
-          </a:solidFill>
-          <a:prstDash val="solid"/>
-          <a:miter lim="800000"/>
-        </a:ln>
         <a:ln w="12700" cap="flat" cmpd="sng" algn="ctr">
           <a:solidFill>
             <a:schemeClr val="phClr"/>
@@ -5798,6 +4408,13 @@
           <a:miter lim="800000"/>
         </a:ln>
         <a:ln w="19050" cap="flat" cmpd="sng" algn="ctr">
+          <a:solidFill>
+            <a:schemeClr val="phClr"/>
+          </a:solidFill>
+          <a:prstDash val="solid"/>
+          <a:miter lim="800000"/>
+        </a:ln>
+        <a:ln w="25400" cap="flat" cmpd="sng" algn="ctr">
           <a:solidFill>
             <a:schemeClr val="phClr"/>
           </a:solidFill>
@@ -5862,11 +4479,31 @@
       </a:bgFillStyleLst>
     </a:fmtScheme>
   </a:themeElements>
-  <a:objectDefaults/>
+  <a:objectDefaults>
+    <a:lnDef>
+      <a:spPr/>
+      <a:bodyPr/>
+      <a:lstStyle/>
+      <a:style>
+        <a:lnRef idx="2">
+          <a:schemeClr val="accent1"/>
+        </a:lnRef>
+        <a:fillRef idx="0">
+          <a:schemeClr val="accent1"/>
+        </a:fillRef>
+        <a:effectRef idx="1">
+          <a:schemeClr val="accent1"/>
+        </a:effectRef>
+        <a:fontRef idx="minor">
+          <a:schemeClr val="tx1"/>
+        </a:fontRef>
+      </a:style>
+    </a:lnDef>
+  </a:objectDefaults>
   <a:extraClrSchemeLst/>
   <a:extLst>
     <a:ext uri="{05A4C25C-085E-4340-85A3-A5531E510DB2}">
-      <thm15:themeFamily xmlns:thm15="http://schemas.microsoft.com/office/thememl/2012/main" name="Office Theme" id="{62F939B6-93AF-4DB8-9C6B-D6C7DFDC589F}" vid="{4A3C46E8-61CC-4603-A589-7422A47A8E4A}"/>
+      <thm15:themeFamily xmlns:thm15="http://schemas.microsoft.com/office/thememl/2012/main" name="Office Theme" id="{2E142A2C-CD16-42D6-873A-C26D2A0506FA}" vid="{97E0A228-C590-4D20-B05F-A6BF04A05448}"/>
     </a:ext>
   </a:extLst>
 </a:theme>
@@ -6185,4 +4822,47 @@
     </a:ext>
   </a:extLst>
 </a:theme>
+</file>
+
+<file path=ppt/theme/themeOverride1.xml><?xml version="1.0" encoding="utf-8"?>
+<a:themeOverride xmlns:a="http://schemas.openxmlformats.org/drawingml/2006/main">
+  <a:clrScheme name="Office 2013 - 2022">
+    <a:dk1>
+      <a:sysClr val="windowText" lastClr="000000"/>
+    </a:dk1>
+    <a:lt1>
+      <a:sysClr val="window" lastClr="FFFFFF"/>
+    </a:lt1>
+    <a:dk2>
+      <a:srgbClr val="44546A"/>
+    </a:dk2>
+    <a:lt2>
+      <a:srgbClr val="E7E6E6"/>
+    </a:lt2>
+    <a:accent1>
+      <a:srgbClr val="4472C4"/>
+    </a:accent1>
+    <a:accent2>
+      <a:srgbClr val="ED7D31"/>
+    </a:accent2>
+    <a:accent3>
+      <a:srgbClr val="A5A5A5"/>
+    </a:accent3>
+    <a:accent4>
+      <a:srgbClr val="FFC000"/>
+    </a:accent4>
+    <a:accent5>
+      <a:srgbClr val="5B9BD5"/>
+    </a:accent5>
+    <a:accent6>
+      <a:srgbClr val="70AD47"/>
+    </a:accent6>
+    <a:hlink>
+      <a:srgbClr val="0563C1"/>
+    </a:hlink>
+    <a:folHlink>
+      <a:srgbClr val="954F72"/>
+    </a:folHlink>
+  </a:clrScheme>
+</a:themeOverride>
 </file>
</xml_diff>